<commit_message>
Fix widescreen layout and card alignment across all slides
</commit_message>
<xml_diff>
--- a/Sudoku_CSP_Presentation.pptx
+++ b/Sudoku_CSP_Presentation.pptx
@@ -19,8 +19,8 @@
   <p:notesMasterIdLst>
     <p:notesMasterId r:id="rId12"/>
   </p:notesMasterIdLst>
-  <p:sldSz cx="9144000" cy="5143500"/>
-  <p:notesSz cx="5143500" cy="9144000"/>
+  <p:sldSz cx="12192000" cy="6858000"/>
+  <p:notesSz cx="6858000" cy="12192000"/>
   <p:defaultTextStyle>
     <a:lvl1pPr marL="0" algn="l" defTabSz="914400" rtl="0" eaLnBrk="1" latinLnBrk="0" hangingPunct="1">
       <a:defRPr sz="1800" kern="1200">
@@ -511,7 +511,7 @@
           <a:p>
             <a:r>
               <a:rPr lang="en-US" dirty="0"/>
-              <a:t>Good morning/afternoon respected professors and examiners. Today, I am presenting my project on solving Sudoku modeled as a Constraint Satisfaction Problem within Artificial Intelligence. We formulate the game under the standard CSP triplet framework, explore systematic backtracking search with branch pruning, and demonstrate an interactive, full-stack implementation with real-time constraint validation.</a:t>
+              <a:t>Good morning/afternoon respected professors and examiners. Today, I am presenting my project on solving Sudoku modeled as a Constraint Satisfaction Problem within Artificial Intelligence. We formulate the game under the standard CSP triplet framework, explore systematic backtracking search with branch pruning, and demonstrate an interactive implementation with real-time constraint validation.</a:t>
             </a:r>
             <a:endParaRPr lang="en-US" dirty="0"/>
           </a:p>
@@ -1685,7 +1685,7 @@
         <p:spPr>
           <a:xfrm>
             <a:off x="0" y="0"/>
-            <a:ext cx="12188952" cy="137160"/>
+            <a:ext cx="12191695" cy="109728"/>
           </a:xfrm>
           <a:prstGeom prst="rect">
             <a:avLst/>
@@ -1709,8 +1709,8 @@
         </p:nvSpPr>
         <p:spPr>
           <a:xfrm>
-            <a:off x="914400" y="1645920"/>
-            <a:ext cx="10360152" cy="365760"/>
+            <a:off x="914400" y="1097280"/>
+            <a:ext cx="10360152" cy="320040"/>
           </a:xfrm>
           <a:prstGeom prst="rect">
             <a:avLst/>
@@ -1726,7 +1726,7 @@
               <a:buNone/>
             </a:pPr>
             <a:r>
-              <a:rPr lang="en-US" sz="1400" b="1" spc="200" kern="0" dirty="0">
+              <a:rPr lang="en-US" sz="1300" b="1" spc="200" kern="0" dirty="0">
                 <a:solidFill>
                   <a:srgbClr val="38BDF8"/>
                 </a:solidFill>
@@ -1736,7 +1736,7 @@
               </a:rPr>
               <a:t>ARTIFICIAL INTELLIGENCE &amp; SOFT COMPUTING</a:t>
             </a:r>
-            <a:endParaRPr lang="en-US" sz="1400" dirty="0"/>
+            <a:endParaRPr lang="en-US" sz="1300" dirty="0"/>
           </a:p>
         </p:txBody>
       </p:sp>
@@ -1748,8 +1748,8 @@
         </p:nvSpPr>
         <p:spPr>
           <a:xfrm>
-            <a:off x="914400" y="2103120"/>
-            <a:ext cx="10360152" cy="1371600"/>
+            <a:off x="914400" y="1508760"/>
+            <a:ext cx="10360152" cy="1280160"/>
           </a:xfrm>
           <a:prstGeom prst="rect">
             <a:avLst/>
@@ -1765,7 +1765,7 @@
               <a:buNone/>
             </a:pPr>
             <a:r>
-              <a:rPr lang="en-US" sz="3400" b="1" dirty="0">
+              <a:rPr lang="en-US" sz="3200" b="1" dirty="0">
                 <a:solidFill>
                   <a:srgbClr val="FFFFFF"/>
                 </a:solidFill>
@@ -1775,7 +1775,7 @@
               </a:rPr>
               <a:t>Sudoku Solver Using Constraint Satisfaction Problem (CSP)</a:t>
             </a:r>
-            <a:endParaRPr lang="en-US" sz="3400" dirty="0"/>
+            <a:endParaRPr lang="en-US" sz="3200" dirty="0"/>
           </a:p>
         </p:txBody>
       </p:sp>
@@ -1787,8 +1787,8 @@
         </p:nvSpPr>
         <p:spPr>
           <a:xfrm>
-            <a:off x="914400" y="3566160"/>
-            <a:ext cx="10360152" cy="457200"/>
+            <a:off x="914400" y="2926080"/>
+            <a:ext cx="10360152" cy="411480"/>
           </a:xfrm>
           <a:prstGeom prst="rect">
             <a:avLst/>
@@ -1804,7 +1804,7 @@
               <a:buNone/>
             </a:pPr>
             <a:r>
-              <a:rPr lang="en-US" sz="1800" dirty="0">
+              <a:rPr lang="en-US" sz="1700" dirty="0">
                 <a:solidFill>
                   <a:srgbClr val="94A3B8"/>
                 </a:solidFill>
@@ -1814,7 +1814,7 @@
               </a:rPr>
               <a:t>Modeling, State-Space Search, Backtracking, and Heuristics</a:t>
             </a:r>
-            <a:endParaRPr lang="en-US" sz="1800" dirty="0"/>
+            <a:endParaRPr lang="en-US" sz="1700" dirty="0"/>
           </a:p>
         </p:txBody>
       </p:sp>
@@ -1826,12 +1826,12 @@
         </p:nvSpPr>
         <p:spPr>
           <a:xfrm>
-            <a:off x="914400" y="4572000"/>
-            <a:ext cx="10360152" cy="1280160"/>
+            <a:off x="914400" y="3749040"/>
+            <a:ext cx="10360152" cy="2286000"/>
           </a:xfrm>
           <a:prstGeom prst="roundRect">
             <a:avLst>
-              <a:gd name="adj" fmla="val 7143"/>
+              <a:gd name="adj" fmla="val 4000"/>
             </a:avLst>
           </a:prstGeom>
           <a:solidFill>
@@ -1853,8 +1853,8 @@
         </p:nvSpPr>
         <p:spPr>
           <a:xfrm>
-            <a:off x="1188720" y="4754880"/>
-            <a:ext cx="9784080" cy="914400"/>
+            <a:off x="1188720" y="3977640"/>
+            <a:ext cx="9784080" cy="1828800"/>
           </a:xfrm>
           <a:prstGeom prst="rect">
             <a:avLst/>
@@ -1870,7 +1870,7 @@
               <a:buNone/>
             </a:pPr>
             <a:r>
-              <a:rPr lang="en-US" sz="1300" b="1" dirty="0">
+              <a:rPr lang="en-US" sz="1350" b="1" dirty="0">
                 <a:solidFill>
                   <a:srgbClr val="FFFFFF"/>
                 </a:solidFill>
@@ -1878,28 +1878,28 @@
                 <a:ea typeface="Calibri" pitchFamily="34" charset="-122"/>
                 <a:cs typeface="Calibri" pitchFamily="34" charset="-120"/>
               </a:rPr>
-              <a:t>Core Paradigms: </a:t>
-            </a:r>
-            <a:pPr indent="0" marL="0">
-              <a:buNone/>
-            </a:pPr>
-            <a:r>
-              <a:rPr lang="en-US" sz="1300" dirty="0">
-                <a:solidFill>
-                  <a:srgbClr val="94A3B8"/>
-                </a:solidFill>
-                <a:latin typeface="Calibri" pitchFamily="34" charset="0"/>
-                <a:ea typeface="Calibri" pitchFamily="34" charset="-122"/>
-                <a:cs typeface="Calibri" pitchFamily="34" charset="-120"/>
-              </a:rPr>
-              <a:t>Constraint Satisfaction Problems (CSP) • Depth-First Search with Backtracking • Heuristic Pruning
+              <a:t>Presenter / Author: </a:t>
+            </a:r>
+            <a:pPr indent="0" marL="0">
+              <a:buNone/>
+            </a:pPr>
+            <a:r>
+              <a:rPr lang="en-US" sz="1350" b="1" dirty="0">
+                <a:solidFill>
+                  <a:srgbClr val="38BDF8"/>
+                </a:solidFill>
+                <a:latin typeface="Calibri" pitchFamily="34" charset="0"/>
+                <a:ea typeface="Calibri" pitchFamily="34" charset="-122"/>
+                <a:cs typeface="Calibri" pitchFamily="34" charset="-120"/>
+              </a:rPr>
+              <a:t>Aastha Dhoundiyal
 </a:t>
             </a:r>
             <a:pPr indent="0" marL="0">
               <a:buNone/>
             </a:pPr>
             <a:r>
-              <a:rPr lang="en-US" sz="1300" b="1" dirty="0">
+              <a:rPr lang="en-US" sz="1350" b="1" dirty="0">
                 <a:solidFill>
                   <a:srgbClr val="FFFFFF"/>
                 </a:solidFill>
@@ -1907,23 +1907,52 @@
                 <a:ea typeface="Calibri" pitchFamily="34" charset="-122"/>
                 <a:cs typeface="Calibri" pitchFamily="34" charset="-120"/>
               </a:rPr>
-              <a:t>Application: </a:t>
-            </a:r>
-            <a:pPr indent="0" marL="0">
-              <a:buNone/>
-            </a:pPr>
-            <a:r>
-              <a:rPr lang="en-US" sz="1300" dirty="0">
-                <a:solidFill>
-                  <a:srgbClr val="94A3B8"/>
-                </a:solidFill>
-                <a:latin typeface="Calibri" pitchFamily="34" charset="0"/>
-                <a:ea typeface="Calibri" pitchFamily="34" charset="-122"/>
-                <a:cs typeface="Calibri" pitchFamily="34" charset="-120"/>
-              </a:rPr>
-              <a:t>Interactive Intelligent Solver &amp; Real-Time Conflict Detection Engine (React + Vite)</a:t>
-            </a:r>
-            <a:endParaRPr lang="en-US" sz="1300" dirty="0"/>
+              <a:t>Core AI Paradigms: </a:t>
+            </a:r>
+            <a:pPr indent="0" marL="0">
+              <a:buNone/>
+            </a:pPr>
+            <a:r>
+              <a:rPr lang="en-US" sz="1350" dirty="0">
+                <a:solidFill>
+                  <a:srgbClr val="94A3B8"/>
+                </a:solidFill>
+                <a:latin typeface="Calibri" pitchFamily="34" charset="0"/>
+                <a:ea typeface="Calibri" pitchFamily="34" charset="-122"/>
+                <a:cs typeface="Calibri" pitchFamily="34" charset="-120"/>
+              </a:rPr>
+              <a:t>Constraint Satisfaction Problems (CSP) • State-Space Representation • Depth-First Search with Backtracking
+</a:t>
+            </a:r>
+            <a:pPr indent="0" marL="0">
+              <a:buNone/>
+            </a:pPr>
+            <a:r>
+              <a:rPr lang="en-US" sz="1350" b="1" dirty="0">
+                <a:solidFill>
+                  <a:srgbClr val="FFFFFF"/>
+                </a:solidFill>
+                <a:latin typeface="Calibri" pitchFamily="34" charset="0"/>
+                <a:ea typeface="Calibri" pitchFamily="34" charset="-122"/>
+                <a:cs typeface="Calibri" pitchFamily="34" charset="-120"/>
+              </a:rPr>
+              <a:t>Interactive Web Engine: </a:t>
+            </a:r>
+            <a:pPr indent="0" marL="0">
+              <a:buNone/>
+            </a:pPr>
+            <a:r>
+              <a:rPr lang="en-US" sz="1350" dirty="0">
+                <a:solidFill>
+                  <a:srgbClr val="94A3B8"/>
+                </a:solidFill>
+                <a:latin typeface="Calibri" pitchFamily="34" charset="0"/>
+                <a:ea typeface="Calibri" pitchFamily="34" charset="-122"/>
+                <a:cs typeface="Calibri" pitchFamily="34" charset="-120"/>
+              </a:rPr>
+              <a:t>React + Vite UI with Real-Time Conflict Detection and Verification</a:t>
+            </a:r>
+            <a:endParaRPr lang="en-US" sz="1350" dirty="0"/>
           </a:p>
         </p:txBody>
       </p:sp>
@@ -1967,8 +1996,8 @@
         </p:nvSpPr>
         <p:spPr>
           <a:xfrm>
-            <a:off x="731520" y="457200"/>
-            <a:ext cx="7315200" cy="274320"/>
+            <a:off x="731520" y="411480"/>
+            <a:ext cx="9144000" cy="274320"/>
           </a:xfrm>
           <a:prstGeom prst="rect">
             <a:avLst/>
@@ -2006,8 +2035,8 @@
         </p:nvSpPr>
         <p:spPr>
           <a:xfrm>
-            <a:off x="731520" y="731520"/>
-            <a:ext cx="10515600" cy="640080"/>
+            <a:off x="731520" y="685800"/>
+            <a:ext cx="10698480" cy="548640"/>
           </a:xfrm>
           <a:prstGeom prst="rect">
             <a:avLst/>
@@ -2023,7 +2052,7 @@
               <a:buNone/>
             </a:pPr>
             <a:r>
-              <a:rPr lang="en-US" sz="2400" b="1" dirty="0">
+              <a:rPr lang="en-US" sz="2200" b="1" dirty="0">
                 <a:solidFill>
                   <a:srgbClr val="FFFFFF"/>
                 </a:solidFill>
@@ -2033,7 +2062,7 @@
               </a:rPr>
               <a:t>Project Summary &amp; Future Horizons</a:t>
             </a:r>
-            <a:endParaRPr lang="en-US" sz="2400" dirty="0"/>
+            <a:endParaRPr lang="en-US" sz="2200" dirty="0"/>
           </a:p>
         </p:txBody>
       </p:sp>
@@ -2045,8 +2074,8 @@
         </p:nvSpPr>
         <p:spPr>
           <a:xfrm>
-            <a:off x="731520" y="1417320"/>
-            <a:ext cx="10698480" cy="18288"/>
+            <a:off x="731520" y="1298448"/>
+            <a:ext cx="10725912" cy="18288"/>
           </a:xfrm>
           <a:prstGeom prst="rect">
             <a:avLst/>
@@ -2070,12 +2099,12 @@
         </p:nvSpPr>
         <p:spPr>
           <a:xfrm>
-            <a:off x="731520" y="1645920"/>
-            <a:ext cx="10698480" cy="4389120"/>
+            <a:off x="731520" y="1508760"/>
+            <a:ext cx="10725912" cy="4754880"/>
           </a:xfrm>
           <a:prstGeom prst="roundRect">
             <a:avLst>
-              <a:gd name="adj" fmla="val 2083"/>
+              <a:gd name="adj" fmla="val 1923"/>
             </a:avLst>
           </a:prstGeom>
           <a:solidFill>
@@ -2097,8 +2126,8 @@
         </p:nvSpPr>
         <p:spPr>
           <a:xfrm>
-            <a:off x="1005840" y="1920240"/>
-            <a:ext cx="10058400" cy="365760"/>
+            <a:off x="1005840" y="1783080"/>
+            <a:ext cx="10177272" cy="365760"/>
           </a:xfrm>
           <a:prstGeom prst="rect">
             <a:avLst/>
@@ -2136,8 +2165,8 @@
         </p:nvSpPr>
         <p:spPr>
           <a:xfrm>
-            <a:off x="1005840" y="2468880"/>
-            <a:ext cx="10058400" cy="3200400"/>
+            <a:off x="1005840" y="2331720"/>
+            <a:ext cx="10177272" cy="3474720"/>
           </a:xfrm>
           <a:prstGeom prst="rect">
             <a:avLst/>
@@ -2308,8 +2337,8 @@
         </p:nvSpPr>
         <p:spPr>
           <a:xfrm>
-            <a:off x="731520" y="457200"/>
-            <a:ext cx="7315200" cy="274320"/>
+            <a:off x="731520" y="411480"/>
+            <a:ext cx="9144000" cy="274320"/>
           </a:xfrm>
           <a:prstGeom prst="rect">
             <a:avLst/>
@@ -2347,8 +2376,8 @@
         </p:nvSpPr>
         <p:spPr>
           <a:xfrm>
-            <a:off x="731520" y="731520"/>
-            <a:ext cx="10515600" cy="640080"/>
+            <a:off x="731520" y="685800"/>
+            <a:ext cx="10698480" cy="548640"/>
           </a:xfrm>
           <a:prstGeom prst="rect">
             <a:avLst/>
@@ -2364,7 +2393,7 @@
               <a:buNone/>
             </a:pPr>
             <a:r>
-              <a:rPr lang="en-US" sz="2400" b="1" dirty="0">
+              <a:rPr lang="en-US" sz="2200" b="1" dirty="0">
                 <a:solidFill>
                   <a:srgbClr val="FFFFFF"/>
                 </a:solidFill>
@@ -2374,7 +2403,7 @@
               </a:rPr>
               <a:t>Why Constraint Satisfaction for Sudoku?</a:t>
             </a:r>
-            <a:endParaRPr lang="en-US" sz="2400" dirty="0"/>
+            <a:endParaRPr lang="en-US" sz="2200" dirty="0"/>
           </a:p>
         </p:txBody>
       </p:sp>
@@ -2386,8 +2415,8 @@
         </p:nvSpPr>
         <p:spPr>
           <a:xfrm>
-            <a:off x="731520" y="1417320"/>
-            <a:ext cx="10698480" cy="18288"/>
+            <a:off x="731520" y="1298448"/>
+            <a:ext cx="10725912" cy="18288"/>
           </a:xfrm>
           <a:prstGeom prst="rect">
             <a:avLst/>
@@ -2411,12 +2440,12 @@
         </p:nvSpPr>
         <p:spPr>
           <a:xfrm>
-            <a:off x="731520" y="1645920"/>
-            <a:ext cx="5120640" cy="4389120"/>
+            <a:off x="731520" y="1508760"/>
+            <a:ext cx="5212080" cy="4754880"/>
           </a:xfrm>
           <a:prstGeom prst="roundRect">
             <a:avLst>
-              <a:gd name="adj" fmla="val 2083"/>
+              <a:gd name="adj" fmla="val 1923"/>
             </a:avLst>
           </a:prstGeom>
           <a:solidFill>
@@ -2438,8 +2467,8 @@
         </p:nvSpPr>
         <p:spPr>
           <a:xfrm>
-            <a:off x="1005840" y="1828800"/>
-            <a:ext cx="4572000" cy="365760"/>
+            <a:off x="1005840" y="1737360"/>
+            <a:ext cx="4663440" cy="365760"/>
           </a:xfrm>
           <a:prstGeom prst="rect">
             <a:avLst/>
@@ -2477,8 +2506,8 @@
         </p:nvSpPr>
         <p:spPr>
           <a:xfrm>
-            <a:off x="1005840" y="2286000"/>
-            <a:ext cx="4572000" cy="3474720"/>
+            <a:off x="1005840" y="2240280"/>
+            <a:ext cx="4663440" cy="3749040"/>
           </a:xfrm>
           <a:prstGeom prst="rect">
             <a:avLst/>
@@ -2516,7 +2545,7 @@
                 <a:ea typeface="Calibri" pitchFamily="34" charset="-122"/>
                 <a:cs typeface="Calibri" pitchFamily="34" charset="-120"/>
               </a:rPr>
-              <a:t>A blank 9x9 grid has 81 cells, yielding 9^81 (~1.96 × 10^77) possible configurations.
+              <a:t>A blank 9x9 grid has 81 cells, producing 9^81 (~1.96 × 10^77) possible configurations.
 </a:t>
             </a:r>
             <a:pPr indent="0" marL="0">
@@ -2545,7 +2574,7 @@
                 <a:ea typeface="Calibri" pitchFamily="34" charset="-122"/>
                 <a:cs typeface="Calibri" pitchFamily="34" charset="-120"/>
               </a:rPr>
-              <a:t>Standard BFS or DFS without domain constraints will blindly explore dead paths, hitting exponential explosion.
+              <a:t>Standard BFS or DFS without domain rules will blindly explore dead paths, hitting exponential explosion.
 </a:t>
             </a:r>
             <a:pPr indent="0" marL="0">
@@ -2588,12 +2617,12 @@
         </p:nvSpPr>
         <p:spPr>
           <a:xfrm>
-            <a:off x="6217920" y="1645920"/>
-            <a:ext cx="5212080" cy="4389120"/>
+            <a:off x="6245352" y="1508760"/>
+            <a:ext cx="5212080" cy="4754880"/>
           </a:xfrm>
           <a:prstGeom prst="roundRect">
             <a:avLst>
-              <a:gd name="adj" fmla="val 2083"/>
+              <a:gd name="adj" fmla="val 1923"/>
             </a:avLst>
           </a:prstGeom>
           <a:solidFill>
@@ -2615,7 +2644,7 @@
         </p:nvSpPr>
         <p:spPr>
           <a:xfrm>
-            <a:off x="6492240" y="1828800"/>
+            <a:off x="6519672" y="1737360"/>
             <a:ext cx="4663440" cy="365760"/>
           </a:xfrm>
           <a:prstGeom prst="rect">
@@ -2654,8 +2683,8 @@
         </p:nvSpPr>
         <p:spPr>
           <a:xfrm>
-            <a:off x="6492240" y="2286000"/>
-            <a:ext cx="4663440" cy="3474720"/>
+            <a:off x="6519672" y="2240280"/>
+            <a:ext cx="4663440" cy="3749040"/>
           </a:xfrm>
           <a:prstGeom prst="rect">
             <a:avLst/>
@@ -2797,8 +2826,8 @@
         </p:nvSpPr>
         <p:spPr>
           <a:xfrm>
-            <a:off x="731520" y="457200"/>
-            <a:ext cx="7315200" cy="274320"/>
+            <a:off x="731520" y="411480"/>
+            <a:ext cx="9144000" cy="274320"/>
           </a:xfrm>
           <a:prstGeom prst="rect">
             <a:avLst/>
@@ -2836,8 +2865,8 @@
         </p:nvSpPr>
         <p:spPr>
           <a:xfrm>
-            <a:off x="731520" y="731520"/>
-            <a:ext cx="10515600" cy="640080"/>
+            <a:off x="731520" y="685800"/>
+            <a:ext cx="10698480" cy="548640"/>
           </a:xfrm>
           <a:prstGeom prst="rect">
             <a:avLst/>
@@ -2853,7 +2882,7 @@
               <a:buNone/>
             </a:pPr>
             <a:r>
-              <a:rPr lang="en-US" sz="2400" b="1" dirty="0">
+              <a:rPr lang="en-US" sz="2200" b="1" dirty="0">
                 <a:solidFill>
                   <a:srgbClr val="FFFFFF"/>
                 </a:solidFill>
@@ -2863,7 +2892,7 @@
               </a:rPr>
               <a:t>Formal CSP Formulation: &lt;X, D, C&gt;</a:t>
             </a:r>
-            <a:endParaRPr lang="en-US" sz="2400" dirty="0"/>
+            <a:endParaRPr lang="en-US" sz="2200" dirty="0"/>
           </a:p>
         </p:txBody>
       </p:sp>
@@ -2875,8 +2904,8 @@
         </p:nvSpPr>
         <p:spPr>
           <a:xfrm>
-            <a:off x="731520" y="1417320"/>
-            <a:ext cx="10698480" cy="18288"/>
+            <a:off x="731520" y="1298448"/>
+            <a:ext cx="10725912" cy="18288"/>
           </a:xfrm>
           <a:prstGeom prst="rect">
             <a:avLst/>
@@ -2900,8 +2929,8 @@
         </p:nvSpPr>
         <p:spPr>
           <a:xfrm>
-            <a:off x="731520" y="1645920"/>
-            <a:ext cx="3337560" cy="4389120"/>
+            <a:off x="731520" y="1508760"/>
+            <a:ext cx="3337560" cy="4754880"/>
           </a:xfrm>
           <a:prstGeom prst="roundRect">
             <a:avLst>
@@ -2927,8 +2956,8 @@
         </p:nvSpPr>
         <p:spPr>
           <a:xfrm>
-            <a:off x="914400" y="1828800"/>
-            <a:ext cx="2971800" cy="365760"/>
+            <a:off x="914400" y="1737360"/>
+            <a:ext cx="2971800" cy="320040"/>
           </a:xfrm>
           <a:prstGeom prst="rect">
             <a:avLst/>
@@ -2966,8 +2995,8 @@
         </p:nvSpPr>
         <p:spPr>
           <a:xfrm>
-            <a:off x="914400" y="2286000"/>
-            <a:ext cx="2971800" cy="3474720"/>
+            <a:off x="914400" y="2240280"/>
+            <a:ext cx="2971800" cy="3749040"/>
           </a:xfrm>
           <a:prstGeom prst="rect">
             <a:avLst/>
@@ -3021,7 +3050,7 @@
                 <a:ea typeface="Calibri" pitchFamily="34" charset="-122"/>
                 <a:cs typeface="Calibri" pitchFamily="34" charset="-120"/>
               </a:rPr>
-              <a:t>Each variable X_r,c represents the value to be assigned to the cell at row r and column c.
+              <a:t>Each variable X_r,c represents the value assigned to the cell at row r and column c.
 </a:t>
             </a:r>
             <a:pPr indent="0" marL="0">
@@ -3093,8 +3122,8 @@
         </p:nvSpPr>
         <p:spPr>
           <a:xfrm>
-            <a:off x="4389120" y="1645920"/>
-            <a:ext cx="3337560" cy="4389120"/>
+            <a:off x="4425696" y="1508760"/>
+            <a:ext cx="3337560" cy="4754880"/>
           </a:xfrm>
           <a:prstGeom prst="roundRect">
             <a:avLst>
@@ -3120,8 +3149,8 @@
         </p:nvSpPr>
         <p:spPr>
           <a:xfrm>
-            <a:off x="4572000" y="1828800"/>
-            <a:ext cx="2971800" cy="365760"/>
+            <a:off x="4608576" y="1737360"/>
+            <a:ext cx="2971800" cy="320040"/>
           </a:xfrm>
           <a:prstGeom prst="rect">
             <a:avLst/>
@@ -3159,8 +3188,8 @@
         </p:nvSpPr>
         <p:spPr>
           <a:xfrm>
-            <a:off x="4572000" y="2286000"/>
-            <a:ext cx="2971800" cy="3474720"/>
+            <a:off x="4608576" y="2240280"/>
+            <a:ext cx="2971800" cy="3749040"/>
           </a:xfrm>
           <a:prstGeom prst="rect">
             <a:avLst/>
@@ -3228,7 +3257,7 @@
                 <a:ea typeface="Calibri" pitchFamily="34" charset="-122"/>
                 <a:cs typeface="Calibri" pitchFamily="34" charset="-120"/>
               </a:rPr>
-              <a:t>D_r,c = { 1, 2, 3, 4, 5, 6, 7, 8, 9 } initially.
+              <a:t>D_r,c = { 1..9 } initially.
 </a:t>
             </a:r>
             <a:pPr indent="0" marL="0">
@@ -3286,7 +3315,7 @@
                 <a:ea typeface="Calibri" pitchFamily="34" charset="-122"/>
                 <a:cs typeface="Calibri" pitchFamily="34" charset="-120"/>
               </a:rPr>
-              <a:t>As neighboring cells are assigned, illegal values are removed.</a:t>
+              <a:t>Neighbor assignments eliminate invalid numbers.</a:t>
             </a:r>
             <a:endParaRPr lang="en-US" sz="1250" dirty="0"/>
           </a:p>
@@ -3300,8 +3329,8 @@
         </p:nvSpPr>
         <p:spPr>
           <a:xfrm>
-            <a:off x="8046720" y="1645920"/>
-            <a:ext cx="3337560" cy="4389120"/>
+            <a:off x="8119872" y="1508760"/>
+            <a:ext cx="3337560" cy="4754880"/>
           </a:xfrm>
           <a:prstGeom prst="roundRect">
             <a:avLst>
@@ -3327,8 +3356,8 @@
         </p:nvSpPr>
         <p:spPr>
           <a:xfrm>
-            <a:off x="8229600" y="1828800"/>
-            <a:ext cx="2971800" cy="365760"/>
+            <a:off x="8302752" y="1737360"/>
+            <a:ext cx="2971800" cy="320040"/>
           </a:xfrm>
           <a:prstGeom prst="rect">
             <a:avLst/>
@@ -3366,8 +3395,8 @@
         </p:nvSpPr>
         <p:spPr>
           <a:xfrm>
-            <a:off x="8229600" y="2286000"/>
-            <a:ext cx="2971800" cy="3474720"/>
+            <a:off x="8302752" y="2240280"/>
+            <a:ext cx="2971800" cy="3749040"/>
           </a:xfrm>
           <a:prstGeom prst="rect">
             <a:avLst/>
@@ -3539,8 +3568,8 @@
         </p:nvSpPr>
         <p:spPr>
           <a:xfrm>
-            <a:off x="731520" y="457200"/>
-            <a:ext cx="7315200" cy="274320"/>
+            <a:off x="731520" y="411480"/>
+            <a:ext cx="9144000" cy="274320"/>
           </a:xfrm>
           <a:prstGeom prst="rect">
             <a:avLst/>
@@ -3578,8 +3607,8 @@
         </p:nvSpPr>
         <p:spPr>
           <a:xfrm>
-            <a:off x="731520" y="731520"/>
-            <a:ext cx="10515600" cy="640080"/>
+            <a:off x="731520" y="685800"/>
+            <a:ext cx="10698480" cy="548640"/>
           </a:xfrm>
           <a:prstGeom prst="rect">
             <a:avLst/>
@@ -3595,7 +3624,7 @@
               <a:buNone/>
             </a:pPr>
             <a:r>
-              <a:rPr lang="en-US" sz="2400" b="1" dirty="0">
+              <a:rPr lang="en-US" sz="2200" b="1" dirty="0">
                 <a:solidFill>
                   <a:srgbClr val="FFFFFF"/>
                 </a:solidFill>
@@ -3605,7 +3634,7 @@
               </a:rPr>
               <a:t>Graph Architecture &amp; Neighborhood Scope</a:t>
             </a:r>
-            <a:endParaRPr lang="en-US" sz="2400" dirty="0"/>
+            <a:endParaRPr lang="en-US" sz="2200" dirty="0"/>
           </a:p>
         </p:txBody>
       </p:sp>
@@ -3617,8 +3646,8 @@
         </p:nvSpPr>
         <p:spPr>
           <a:xfrm>
-            <a:off x="731520" y="1417320"/>
-            <a:ext cx="10698480" cy="18288"/>
+            <a:off x="731520" y="1298448"/>
+            <a:ext cx="10725912" cy="18288"/>
           </a:xfrm>
           <a:prstGeom prst="rect">
             <a:avLst/>
@@ -3642,12 +3671,12 @@
         </p:nvSpPr>
         <p:spPr>
           <a:xfrm>
-            <a:off x="731520" y="1645920"/>
-            <a:ext cx="5120640" cy="4389120"/>
+            <a:off x="731520" y="1508760"/>
+            <a:ext cx="5212080" cy="4754880"/>
           </a:xfrm>
           <a:prstGeom prst="roundRect">
             <a:avLst>
-              <a:gd name="adj" fmla="val 2083"/>
+              <a:gd name="adj" fmla="val 1923"/>
             </a:avLst>
           </a:prstGeom>
           <a:solidFill>
@@ -3669,8 +3698,8 @@
         </p:nvSpPr>
         <p:spPr>
           <a:xfrm>
-            <a:off x="1005840" y="1828800"/>
-            <a:ext cx="4572000" cy="365760"/>
+            <a:off x="1005840" y="1737360"/>
+            <a:ext cx="4663440" cy="365760"/>
           </a:xfrm>
           <a:prstGeom prst="rect">
             <a:avLst/>
@@ -3708,8 +3737,8 @@
         </p:nvSpPr>
         <p:spPr>
           <a:xfrm>
-            <a:off x="1005840" y="2286000"/>
-            <a:ext cx="4572000" cy="3474720"/>
+            <a:off x="1005840" y="2240280"/>
+            <a:ext cx="4663440" cy="3749040"/>
           </a:xfrm>
           <a:prstGeom prst="rect">
             <a:avLst/>
@@ -3779,7 +3808,7 @@
               </a:rPr>
               <a:t>  - 8 peers in the same row
   - 8 peers in the same column
-  - 4 peers in the same 3x3 box (not sharing row/col)
+  - 4 peers in the same 3x3 box
 </a:t>
             </a:r>
             <a:pPr indent="0" marL="0">
@@ -3874,12 +3903,12 @@
         </p:nvSpPr>
         <p:spPr>
           <a:xfrm>
-            <a:off x="6217920" y="1645920"/>
-            <a:ext cx="5212080" cy="4389120"/>
+            <a:off x="6245352" y="1508760"/>
+            <a:ext cx="5212080" cy="4754880"/>
           </a:xfrm>
           <a:prstGeom prst="roundRect">
             <a:avLst>
-              <a:gd name="adj" fmla="val 2083"/>
+              <a:gd name="adj" fmla="val 1923"/>
             </a:avLst>
           </a:prstGeom>
           <a:solidFill>
@@ -3901,7 +3930,7 @@
         </p:nvSpPr>
         <p:spPr>
           <a:xfrm>
-            <a:off x="6492240" y="1828800"/>
+            <a:off x="6519672" y="1737360"/>
             <a:ext cx="4663440" cy="365760"/>
           </a:xfrm>
           <a:prstGeom prst="rect">
@@ -3940,8 +3969,8 @@
         </p:nvSpPr>
         <p:spPr>
           <a:xfrm>
-            <a:off x="6492240" y="2286000"/>
-            <a:ext cx="4663440" cy="3474720"/>
+            <a:off x="6519672" y="2240280"/>
+            <a:ext cx="4663440" cy="3749040"/>
           </a:xfrm>
           <a:prstGeom prst="rect">
             <a:avLst/>
@@ -4083,8 +4112,8 @@
         </p:nvSpPr>
         <p:spPr>
           <a:xfrm>
-            <a:off x="731520" y="457200"/>
-            <a:ext cx="7315200" cy="274320"/>
+            <a:off x="731520" y="411480"/>
+            <a:ext cx="9144000" cy="274320"/>
           </a:xfrm>
           <a:prstGeom prst="rect">
             <a:avLst/>
@@ -4122,8 +4151,8 @@
         </p:nvSpPr>
         <p:spPr>
           <a:xfrm>
-            <a:off x="731520" y="731520"/>
-            <a:ext cx="10515600" cy="640080"/>
+            <a:off x="731520" y="685800"/>
+            <a:ext cx="10698480" cy="548640"/>
           </a:xfrm>
           <a:prstGeom prst="rect">
             <a:avLst/>
@@ -4139,7 +4168,7 @@
               <a:buNone/>
             </a:pPr>
             <a:r>
-              <a:rPr lang="en-US" sz="2400" b="1" dirty="0">
+              <a:rPr lang="en-US" sz="2200" b="1" dirty="0">
                 <a:solidFill>
                   <a:srgbClr val="FFFFFF"/>
                 </a:solidFill>
@@ -4149,7 +4178,7 @@
               </a:rPr>
               <a:t>Depth-First Search with Backtracking</a:t>
             </a:r>
-            <a:endParaRPr lang="en-US" sz="2400" dirty="0"/>
+            <a:endParaRPr lang="en-US" sz="2200" dirty="0"/>
           </a:p>
         </p:txBody>
       </p:sp>
@@ -4161,8 +4190,8 @@
         </p:nvSpPr>
         <p:spPr>
           <a:xfrm>
-            <a:off x="731520" y="1417320"/>
-            <a:ext cx="10698480" cy="18288"/>
+            <a:off x="731520" y="1298448"/>
+            <a:ext cx="10725912" cy="18288"/>
           </a:xfrm>
           <a:prstGeom prst="rect">
             <a:avLst/>
@@ -4186,8 +4215,8 @@
         </p:nvSpPr>
         <p:spPr>
           <a:xfrm>
-            <a:off x="731520" y="1645920"/>
-            <a:ext cx="3337560" cy="4389120"/>
+            <a:off x="731520" y="1508760"/>
+            <a:ext cx="3337560" cy="4754880"/>
           </a:xfrm>
           <a:prstGeom prst="roundRect">
             <a:avLst>
@@ -4213,8 +4242,8 @@
         </p:nvSpPr>
         <p:spPr>
           <a:xfrm>
-            <a:off x="914400" y="1828800"/>
-            <a:ext cx="2971800" cy="365760"/>
+            <a:off x="914400" y="1737360"/>
+            <a:ext cx="2971800" cy="320040"/>
           </a:xfrm>
           <a:prstGeom prst="rect">
             <a:avLst/>
@@ -4252,8 +4281,8 @@
         </p:nvSpPr>
         <p:spPr>
           <a:xfrm>
-            <a:off x="914400" y="2286000"/>
-            <a:ext cx="2971800" cy="3474720"/>
+            <a:off x="914400" y="2240280"/>
+            <a:ext cx="2971800" cy="3749040"/>
           </a:xfrm>
           <a:prstGeom prst="rect">
             <a:avLst/>
@@ -4292,7 +4321,7 @@
                 <a:ea typeface="Calibri" pitchFamily="34" charset="-122"/>
                 <a:cs typeface="Calibri" pitchFamily="34" charset="-120"/>
               </a:rPr>
-              <a:t>• Scans the grid (r, c) until it finds a cell with value 0.
+              <a:t>• Scans grid (r, c) until it finds cell with value 0.
 </a:t>
             </a:r>
             <a:pPr indent="0" marL="0">
@@ -4321,7 +4350,7 @@
                 <a:ea typeface="Calibri" pitchFamily="34" charset="-122"/>
                 <a:cs typeface="Calibri" pitchFamily="34" charset="-120"/>
               </a:rPr>
-              <a:t>If no cell has value 0, every variable has a consistent assignment. Puzzle is Solved!
+              <a:t>If no cell has value 0, every variable has a consistent assignment. Solved!
 </a:t>
             </a:r>
             <a:pPr indent="0" marL="0">
@@ -4336,7 +4365,7 @@
                 <a:ea typeface="Calibri" pitchFamily="34" charset="-122"/>
                 <a:cs typeface="Calibri" pitchFamily="34" charset="-120"/>
               </a:rPr>
-              <a:t>• Code: </a:t>
+              <a:t>• Code Reference: </a:t>
             </a:r>
             <a:pPr indent="0" marL="0">
               <a:buNone/>
@@ -4364,8 +4393,8 @@
         </p:nvSpPr>
         <p:spPr>
           <a:xfrm>
-            <a:off x="4389120" y="1645920"/>
-            <a:ext cx="3337560" cy="4389120"/>
+            <a:off x="4425696" y="1508760"/>
+            <a:ext cx="3337560" cy="4754880"/>
           </a:xfrm>
           <a:prstGeom prst="roundRect">
             <a:avLst>
@@ -4391,8 +4420,8 @@
         </p:nvSpPr>
         <p:spPr>
           <a:xfrm>
-            <a:off x="4572000" y="1828800"/>
-            <a:ext cx="2971800" cy="365760"/>
+            <a:off x="4608576" y="1737360"/>
+            <a:ext cx="2971800" cy="320040"/>
           </a:xfrm>
           <a:prstGeom prst="rect">
             <a:avLst/>
@@ -4430,8 +4459,8 @@
         </p:nvSpPr>
         <p:spPr>
           <a:xfrm>
-            <a:off x="4572000" y="2286000"/>
-            <a:ext cx="2971800" cy="3474720"/>
+            <a:off x="4608576" y="2240280"/>
+            <a:ext cx="2971800" cy="3749040"/>
           </a:xfrm>
           <a:prstGeom prst="rect">
             <a:avLst/>
@@ -4485,7 +4514,7 @@
                 <a:ea typeface="Calibri" pitchFamily="34" charset="-122"/>
                 <a:cs typeface="Calibri" pitchFamily="34" charset="-120"/>
               </a:rPr>
-              <a:t>• Checks if num already exists in row r, column c, or the 3x3 block.
+              <a:t>• Checks if num exists in row r, col c, or the 3x3 block.
 </a:t>
             </a:r>
             <a:pPr indent="0" marL="0">
@@ -4529,7 +4558,7 @@
                 <a:ea typeface="Calibri" pitchFamily="34" charset="-122"/>
                 <a:cs typeface="Calibri" pitchFamily="34" charset="-120"/>
               </a:rPr>
-              <a:t>• Code: </a:t>
+              <a:t>• Code Reference: </a:t>
             </a:r>
             <a:pPr indent="0" marL="0">
               <a:buNone/>
@@ -4557,8 +4586,8 @@
         </p:nvSpPr>
         <p:spPr>
           <a:xfrm>
-            <a:off x="8046720" y="1645920"/>
-            <a:ext cx="3337560" cy="4389120"/>
+            <a:off x="8119872" y="1508760"/>
+            <a:ext cx="3337560" cy="4754880"/>
           </a:xfrm>
           <a:prstGeom prst="roundRect">
             <a:avLst>
@@ -4584,8 +4613,8 @@
         </p:nvSpPr>
         <p:spPr>
           <a:xfrm>
-            <a:off x="8229600" y="1828800"/>
-            <a:ext cx="2971800" cy="365760"/>
+            <a:off x="8302752" y="1737360"/>
+            <a:ext cx="2971800" cy="320040"/>
           </a:xfrm>
           <a:prstGeom prst="rect">
             <a:avLst/>
@@ -4609,7 +4638,7 @@
                 <a:ea typeface="Calibri" pitchFamily="34" charset="-122"/>
                 <a:cs typeface="Calibri" pitchFamily="34" charset="-120"/>
               </a:rPr>
-              <a:t>3. Recursive Step &amp; Backtrack</a:t>
+              <a:t>3. Recursive Backtrack</a:t>
             </a:r>
             <a:endParaRPr lang="en-US" sz="1500" dirty="0"/>
           </a:p>
@@ -4623,8 +4652,8 @@
         </p:nvSpPr>
         <p:spPr>
           <a:xfrm>
-            <a:off x="8229600" y="2286000"/>
-            <a:ext cx="2971800" cy="3474720"/>
+            <a:off x="8302752" y="2240280"/>
+            <a:ext cx="2971800" cy="3749040"/>
           </a:xfrm>
           <a:prstGeom prst="rect">
             <a:avLst/>
@@ -4707,7 +4736,7 @@
                 <a:ea typeface="Calibri" pitchFamily="34" charset="-122"/>
                 <a:cs typeface="Calibri" pitchFamily="34" charset="-120"/>
               </a:rPr>
-              <a:t>If recursion returns false, resets board[r][c] = 0 and tries next num.
+              <a:t>If recursion returns false, resets board[r][c] = 0 and tries next candidate.
 </a:t>
             </a:r>
             <a:pPr indent="0" marL="0">
@@ -4722,7 +4751,7 @@
                 <a:ea typeface="Calibri" pitchFamily="34" charset="-122"/>
                 <a:cs typeface="Calibri" pitchFamily="34" charset="-120"/>
               </a:rPr>
-              <a:t>• Code: </a:t>
+              <a:t>• Code Reference: </a:t>
             </a:r>
             <a:pPr indent="0" marL="0">
               <a:buNone/>
@@ -4782,8 +4811,8 @@
         </p:nvSpPr>
         <p:spPr>
           <a:xfrm>
-            <a:off x="731520" y="457200"/>
-            <a:ext cx="7315200" cy="274320"/>
+            <a:off x="731520" y="411480"/>
+            <a:ext cx="9144000" cy="274320"/>
           </a:xfrm>
           <a:prstGeom prst="rect">
             <a:avLst/>
@@ -4821,8 +4850,8 @@
         </p:nvSpPr>
         <p:spPr>
           <a:xfrm>
-            <a:off x="731520" y="731520"/>
-            <a:ext cx="10515600" cy="640080"/>
+            <a:off x="731520" y="685800"/>
+            <a:ext cx="10698480" cy="548640"/>
           </a:xfrm>
           <a:prstGeom prst="rect">
             <a:avLst/>
@@ -4838,7 +4867,7 @@
               <a:buNone/>
             </a:pPr>
             <a:r>
-              <a:rPr lang="en-US" sz="2400" b="1" dirty="0">
+              <a:rPr lang="en-US" sz="2200" b="1" dirty="0">
                 <a:solidFill>
                   <a:srgbClr val="FFFFFF"/>
                 </a:solidFill>
@@ -4848,7 +4877,7 @@
               </a:rPr>
               <a:t>State-Space Tree &amp; Branch Pruning Mechanism</a:t>
             </a:r>
-            <a:endParaRPr lang="en-US" sz="2400" dirty="0"/>
+            <a:endParaRPr lang="en-US" sz="2200" dirty="0"/>
           </a:p>
         </p:txBody>
       </p:sp>
@@ -4860,8 +4889,8 @@
         </p:nvSpPr>
         <p:spPr>
           <a:xfrm>
-            <a:off x="731520" y="1417320"/>
-            <a:ext cx="10698480" cy="18288"/>
+            <a:off x="731520" y="1298448"/>
+            <a:ext cx="10725912" cy="18288"/>
           </a:xfrm>
           <a:prstGeom prst="rect">
             <a:avLst/>
@@ -4885,45 +4914,18 @@
         </p:nvSpPr>
         <p:spPr>
           <a:xfrm>
-            <a:off x="731520" y="1645920"/>
-            <a:ext cx="10698480" cy="4389120"/>
+            <a:off x="731520" y="1508760"/>
+            <a:ext cx="2468880" cy="4754880"/>
           </a:xfrm>
           <a:prstGeom prst="roundRect">
             <a:avLst>
-              <a:gd name="adj" fmla="val 2083"/>
+              <a:gd name="adj" fmla="val 2963"/>
             </a:avLst>
           </a:prstGeom>
           <a:solidFill>
             <a:srgbClr val="1E293B"/>
           </a:solidFill>
-          <a:ln w="12700">
-            <a:solidFill>
-              <a:srgbClr val="334155"/>
-            </a:solidFill>
-            <a:prstDash val="solid"/>
-          </a:ln>
-        </p:spPr>
-      </p:sp>
-      <p:sp>
-        <p:nvSpPr>
-          <p:cNvPr id="6" name="Shape 4"/>
-          <p:cNvSpPr/>
-          <p:nvPr/>
-        </p:nvSpPr>
-        <p:spPr>
-          <a:xfrm>
-            <a:off x="1005840" y="2011680"/>
-            <a:ext cx="2377440" cy="3657600"/>
-          </a:xfrm>
-          <a:prstGeom prst="roundRect">
-            <a:avLst>
-              <a:gd name="adj" fmla="val 3077"/>
-            </a:avLst>
-          </a:prstGeom>
-          <a:solidFill>
-            <a:srgbClr val="0F172A"/>
-          </a:solidFill>
-          <a:ln w="12700">
+          <a:ln w="19050">
             <a:solidFill>
               <a:srgbClr val="38BDF8"/>
             </a:solidFill>
@@ -4933,14 +4935,14 @@
       </p:sp>
       <p:sp>
         <p:nvSpPr>
-          <p:cNvPr id="7" name="Text 5"/>
-          <p:cNvSpPr/>
-          <p:nvPr/>
-        </p:nvSpPr>
-        <p:spPr>
-          <a:xfrm>
-            <a:off x="1097280" y="2194560"/>
-            <a:ext cx="2194560" cy="548640"/>
+          <p:cNvPr id="6" name="Text 4"/>
+          <p:cNvSpPr/>
+          <p:nvPr/>
+        </p:nvSpPr>
+        <p:spPr>
+          <a:xfrm>
+            <a:off x="822960" y="1737360"/>
+            <a:ext cx="2286000" cy="548640"/>
           </a:xfrm>
           <a:prstGeom prst="rect">
             <a:avLst/>
@@ -4956,7 +4958,7 @@
               <a:buNone/>
             </a:pPr>
             <a:r>
-              <a:rPr lang="en-US" sz="1300" b="1" dirty="0">
+              <a:rPr lang="en-US" sz="1400" b="1" dirty="0">
                 <a:solidFill>
                   <a:srgbClr val="38BDF8"/>
                 </a:solidFill>
@@ -4966,14 +4968,14 @@
               </a:rPr>
               <a:t>STATE 1</a:t>
             </a:r>
-            <a:endParaRPr lang="en-US" sz="1300" dirty="0"/>
+            <a:endParaRPr lang="en-US" sz="1400" dirty="0"/>
           </a:p>
           <a:p>
             <a:pPr algn="ctr" indent="0" marL="0">
               <a:buNone/>
             </a:pPr>
             <a:r>
-              <a:rPr lang="en-US" sz="1300" b="1" dirty="0">
+              <a:rPr lang="en-US" sz="1400" b="1" dirty="0">
                 <a:solidFill>
                   <a:srgbClr val="38BDF8"/>
                 </a:solidFill>
@@ -4983,20 +4985,20 @@
               </a:rPr>
               <a:t>Choose Variable</a:t>
             </a:r>
-            <a:endParaRPr lang="en-US" sz="1300" dirty="0"/>
-          </a:p>
-        </p:txBody>
-      </p:sp>
-      <p:sp>
-        <p:nvSpPr>
-          <p:cNvPr id="8" name="Text 6"/>
-          <p:cNvSpPr/>
-          <p:nvPr/>
-        </p:nvSpPr>
-        <p:spPr>
-          <a:xfrm>
-            <a:off x="1097280" y="2834640"/>
-            <a:ext cx="2194560" cy="2560320"/>
+            <a:endParaRPr lang="en-US" sz="1400" dirty="0"/>
+          </a:p>
+        </p:txBody>
+      </p:sp>
+      <p:sp>
+        <p:nvSpPr>
+          <p:cNvPr id="7" name="Text 5"/>
+          <p:cNvSpPr/>
+          <p:nvPr/>
+        </p:nvSpPr>
+        <p:spPr>
+          <a:xfrm>
+            <a:off x="868680" y="2514600"/>
+            <a:ext cx="2194560" cy="3474720"/>
           </a:xfrm>
           <a:prstGeom prst="rect">
             <a:avLst/>
@@ -5012,7 +5014,7 @@
               <a:buNone/>
             </a:pPr>
             <a:r>
-              <a:rPr lang="en-US" sz="1200" dirty="0">
+              <a:rPr lang="en-US" sz="1250" dirty="0">
                 <a:solidFill>
                   <a:srgbClr val="94A3B8"/>
                 </a:solidFill>
@@ -5022,14 +5024,14 @@
               </a:rPr>
               <a:t>Current Cell: (0, 2)</a:t>
             </a:r>
-            <a:endParaRPr lang="en-US" sz="1200" dirty="0"/>
-          </a:p>
-          <a:p>
-            <a:pPr indent="0" marL="0">
-              <a:buNone/>
-            </a:pPr>
-            <a:r>
-              <a:rPr lang="en-US" sz="1200" dirty="0">
+            <a:endParaRPr lang="en-US" sz="1250" dirty="0"/>
+          </a:p>
+          <a:p>
+            <a:pPr indent="0" marL="0">
+              <a:buNone/>
+            </a:pPr>
+            <a:r>
+              <a:rPr lang="en-US" sz="1250" dirty="0">
                 <a:solidFill>
                   <a:srgbClr val="94A3B8"/>
                 </a:solidFill>
@@ -5039,20 +5041,20 @@
               </a:rPr>
               <a:t>Domain: {1, 2, ..., 9}</a:t>
             </a:r>
-            <a:endParaRPr lang="en-US" sz="1200" dirty="0"/>
-          </a:p>
-          <a:p>
-            <a:pPr indent="0" marL="0">
-              <a:buNone/>
-            </a:pPr>
-            <a:endParaRPr lang="en-US" sz="1200" dirty="0"/>
-          </a:p>
-          <a:p>
-            <a:pPr indent="0" marL="0">
-              <a:buNone/>
-            </a:pPr>
-            <a:r>
-              <a:rPr lang="en-US" sz="1200" dirty="0">
+            <a:endParaRPr lang="en-US" sz="1250" dirty="0"/>
+          </a:p>
+          <a:p>
+            <a:pPr indent="0" marL="0">
+              <a:buNone/>
+            </a:pPr>
+            <a:endParaRPr lang="en-US" sz="1250" dirty="0"/>
+          </a:p>
+          <a:p>
+            <a:pPr indent="0" marL="0">
+              <a:buNone/>
+            </a:pPr>
+            <a:r>
+              <a:rPr lang="en-US" sz="1250" dirty="0">
                 <a:solidFill>
                   <a:srgbClr val="94A3B8"/>
                 </a:solidFill>
@@ -5062,14 +5064,14 @@
               </a:rPr>
               <a:t>Candidate: 1</a:t>
             </a:r>
-            <a:endParaRPr lang="en-US" sz="1200" dirty="0"/>
-          </a:p>
-          <a:p>
-            <a:pPr indent="0" marL="0">
-              <a:buNone/>
-            </a:pPr>
-            <a:r>
-              <a:rPr lang="en-US" sz="1200" dirty="0">
+            <a:endParaRPr lang="en-US" sz="1250" dirty="0"/>
+          </a:p>
+          <a:p>
+            <a:pPr indent="0" marL="0">
+              <a:buNone/>
+            </a:pPr>
+            <a:r>
+              <a:rPr lang="en-US" sz="1250" dirty="0">
                 <a:solidFill>
                   <a:srgbClr val="94A3B8"/>
                 </a:solidFill>
@@ -5079,14 +5081,14 @@
               </a:rPr>
               <a:t>Candidate: 2</a:t>
             </a:r>
-            <a:endParaRPr lang="en-US" sz="1200" dirty="0"/>
-          </a:p>
-          <a:p>
-            <a:pPr indent="0" marL="0">
-              <a:buNone/>
-            </a:pPr>
-            <a:r>
-              <a:rPr lang="en-US" sz="1200" dirty="0">
+            <a:endParaRPr lang="en-US" sz="1250" dirty="0"/>
+          </a:p>
+          <a:p>
+            <a:pPr indent="0" marL="0">
+              <a:buNone/>
+            </a:pPr>
+            <a:r>
+              <a:rPr lang="en-US" sz="1250" dirty="0">
                 <a:solidFill>
                   <a:srgbClr val="94A3B8"/>
                 </a:solidFill>
@@ -5096,30 +5098,53 @@
               </a:rPr>
               <a:t>Candidate: 4 (Valid)</a:t>
             </a:r>
-            <a:endParaRPr lang="en-US" sz="1200" dirty="0"/>
-          </a:p>
-        </p:txBody>
-      </p:sp>
-      <p:sp>
-        <p:nvSpPr>
-          <p:cNvPr id="9" name="Shape 7"/>
-          <p:cNvSpPr/>
-          <p:nvPr/>
-        </p:nvSpPr>
-        <p:spPr>
-          <a:xfrm>
-            <a:off x="3657600" y="2011680"/>
-            <a:ext cx="2377440" cy="3657600"/>
+            <a:endParaRPr lang="en-US" sz="1250" dirty="0"/>
+          </a:p>
+          <a:p>
+            <a:pPr indent="0" marL="0">
+              <a:buNone/>
+            </a:pPr>
+            <a:endParaRPr lang="en-US" sz="1250" dirty="0"/>
+          </a:p>
+          <a:p>
+            <a:pPr indent="0" marL="0">
+              <a:buNone/>
+            </a:pPr>
+            <a:r>
+              <a:rPr lang="en-US" sz="1250" dirty="0">
+                <a:solidFill>
+                  <a:srgbClr val="94A3B8"/>
+                </a:solidFill>
+                <a:latin typeface="Calibri" pitchFamily="34" charset="0"/>
+                <a:ea typeface="Calibri" pitchFamily="34" charset="-122"/>
+                <a:cs typeface="Calibri" pitchFamily="34" charset="-120"/>
+              </a:rPr>
+              <a:t>Scans unassigned cells and selects candidate.</a:t>
+            </a:r>
+            <a:endParaRPr lang="en-US" sz="1250" dirty="0"/>
+          </a:p>
+        </p:txBody>
+      </p:sp>
+      <p:sp>
+        <p:nvSpPr>
+          <p:cNvPr id="8" name="Shape 6"/>
+          <p:cNvSpPr/>
+          <p:nvPr/>
+        </p:nvSpPr>
+        <p:spPr>
+          <a:xfrm>
+            <a:off x="3483864" y="1508760"/>
+            <a:ext cx="2468880" cy="4754880"/>
           </a:xfrm>
           <a:prstGeom prst="roundRect">
             <a:avLst>
-              <a:gd name="adj" fmla="val 3077"/>
+              <a:gd name="adj" fmla="val 2963"/>
             </a:avLst>
           </a:prstGeom>
           <a:solidFill>
-            <a:srgbClr val="0F172A"/>
+            <a:srgbClr val="1E293B"/>
           </a:solidFill>
-          <a:ln w="12700">
+          <a:ln w="19050">
             <a:solidFill>
               <a:srgbClr val="EF4444"/>
             </a:solidFill>
@@ -5129,14 +5154,14 @@
       </p:sp>
       <p:sp>
         <p:nvSpPr>
-          <p:cNvPr id="10" name="Text 8"/>
-          <p:cNvSpPr/>
-          <p:nvPr/>
-        </p:nvSpPr>
-        <p:spPr>
-          <a:xfrm>
-            <a:off x="3749040" y="2194560"/>
-            <a:ext cx="2194560" cy="548640"/>
+          <p:cNvPr id="9" name="Text 7"/>
+          <p:cNvSpPr/>
+          <p:nvPr/>
+        </p:nvSpPr>
+        <p:spPr>
+          <a:xfrm>
+            <a:off x="3575304" y="1737360"/>
+            <a:ext cx="2286000" cy="548640"/>
           </a:xfrm>
           <a:prstGeom prst="rect">
             <a:avLst/>
@@ -5152,7 +5177,7 @@
               <a:buNone/>
             </a:pPr>
             <a:r>
-              <a:rPr lang="en-US" sz="1300" b="1" dirty="0">
+              <a:rPr lang="en-US" sz="1400" b="1" dirty="0">
                 <a:solidFill>
                   <a:srgbClr val="EF4444"/>
                 </a:solidFill>
@@ -5162,14 +5187,14 @@
               </a:rPr>
               <a:t>STATE 2</a:t>
             </a:r>
-            <a:endParaRPr lang="en-US" sz="1300" dirty="0"/>
+            <a:endParaRPr lang="en-US" sz="1400" dirty="0"/>
           </a:p>
           <a:p>
             <a:pPr algn="ctr" indent="0" marL="0">
               <a:buNone/>
             </a:pPr>
             <a:r>
-              <a:rPr lang="en-US" sz="1300" b="1" dirty="0">
+              <a:rPr lang="en-US" sz="1400" b="1" dirty="0">
                 <a:solidFill>
                   <a:srgbClr val="EF4444"/>
                 </a:solidFill>
@@ -5179,20 +5204,20 @@
               </a:rPr>
               <a:t>Immediate Pruning</a:t>
             </a:r>
-            <a:endParaRPr lang="en-US" sz="1300" dirty="0"/>
-          </a:p>
-        </p:txBody>
-      </p:sp>
-      <p:sp>
-        <p:nvSpPr>
-          <p:cNvPr id="11" name="Text 9"/>
-          <p:cNvSpPr/>
-          <p:nvPr/>
-        </p:nvSpPr>
-        <p:spPr>
-          <a:xfrm>
-            <a:off x="3749040" y="2834640"/>
-            <a:ext cx="2194560" cy="2560320"/>
+            <a:endParaRPr lang="en-US" sz="1400" dirty="0"/>
+          </a:p>
+        </p:txBody>
+      </p:sp>
+      <p:sp>
+        <p:nvSpPr>
+          <p:cNvPr id="10" name="Text 8"/>
+          <p:cNvSpPr/>
+          <p:nvPr/>
+        </p:nvSpPr>
+        <p:spPr>
+          <a:xfrm>
+            <a:off x="3621024" y="2514600"/>
+            <a:ext cx="2194560" cy="3474720"/>
           </a:xfrm>
           <a:prstGeom prst="rect">
             <a:avLst/>
@@ -5208,7 +5233,7 @@
               <a:buNone/>
             </a:pPr>
             <a:r>
-              <a:rPr lang="en-US" sz="1200" dirty="0">
+              <a:rPr lang="en-US" sz="1250" dirty="0">
                 <a:solidFill>
                   <a:srgbClr val="94A3B8"/>
                 </a:solidFill>
@@ -5218,14 +5243,14 @@
               </a:rPr>
               <a:t>canPlace((0,2), 1) -&gt; ❌</a:t>
             </a:r>
-            <a:endParaRPr lang="en-US" sz="1200" dirty="0"/>
-          </a:p>
-          <a:p>
-            <a:pPr indent="0" marL="0">
-              <a:buNone/>
-            </a:pPr>
-            <a:r>
-              <a:rPr lang="en-US" sz="1200" dirty="0">
+            <a:endParaRPr lang="en-US" sz="1250" dirty="0"/>
+          </a:p>
+          <a:p>
+            <a:pPr indent="0" marL="0">
+              <a:buNone/>
+            </a:pPr>
+            <a:r>
+              <a:rPr lang="en-US" sz="1250" dirty="0">
                 <a:solidFill>
                   <a:srgbClr val="94A3B8"/>
                 </a:solidFill>
@@ -5235,20 +5260,20 @@
               </a:rPr>
               <a:t>(1 already in row 0)</a:t>
             </a:r>
-            <a:endParaRPr lang="en-US" sz="1200" dirty="0"/>
-          </a:p>
-          <a:p>
-            <a:pPr indent="0" marL="0">
-              <a:buNone/>
-            </a:pPr>
-            <a:endParaRPr lang="en-US" sz="1200" dirty="0"/>
-          </a:p>
-          <a:p>
-            <a:pPr indent="0" marL="0">
-              <a:buNone/>
-            </a:pPr>
-            <a:r>
-              <a:rPr lang="en-US" sz="1200" dirty="0">
+            <a:endParaRPr lang="en-US" sz="1250" dirty="0"/>
+          </a:p>
+          <a:p>
+            <a:pPr indent="0" marL="0">
+              <a:buNone/>
+            </a:pPr>
+            <a:endParaRPr lang="en-US" sz="1250" dirty="0"/>
+          </a:p>
+          <a:p>
+            <a:pPr indent="0" marL="0">
+              <a:buNone/>
+            </a:pPr>
+            <a:r>
+              <a:rPr lang="en-US" sz="1250" dirty="0">
                 <a:solidFill>
                   <a:srgbClr val="94A3B8"/>
                 </a:solidFill>
@@ -5258,14 +5283,14 @@
               </a:rPr>
               <a:t>canPlace((0,2), 2) -&gt; ❌</a:t>
             </a:r>
-            <a:endParaRPr lang="en-US" sz="1200" dirty="0"/>
-          </a:p>
-          <a:p>
-            <a:pPr indent="0" marL="0">
-              <a:buNone/>
-            </a:pPr>
-            <a:r>
-              <a:rPr lang="en-US" sz="1200" dirty="0">
+            <a:endParaRPr lang="en-US" sz="1250" dirty="0"/>
+          </a:p>
+          <a:p>
+            <a:pPr indent="0" marL="0">
+              <a:buNone/>
+            </a:pPr>
+            <a:r>
+              <a:rPr lang="en-US" sz="1250" dirty="0">
                 <a:solidFill>
                   <a:srgbClr val="94A3B8"/>
                 </a:solidFill>
@@ -5275,53 +5300,53 @@
               </a:rPr>
               <a:t>(2 already in 3x3 box)</a:t>
             </a:r>
-            <a:endParaRPr lang="en-US" sz="1200" dirty="0"/>
-          </a:p>
-          <a:p>
-            <a:pPr indent="0" marL="0">
-              <a:buNone/>
-            </a:pPr>
-            <a:endParaRPr lang="en-US" sz="1200" dirty="0"/>
-          </a:p>
-          <a:p>
-            <a:pPr indent="0" marL="0">
-              <a:buNone/>
-            </a:pPr>
-            <a:r>
-              <a:rPr lang="en-US" sz="1200" dirty="0">
-                <a:solidFill>
-                  <a:srgbClr val="94A3B8"/>
-                </a:solidFill>
-                <a:latin typeface="Calibri" pitchFamily="34" charset="0"/>
-                <a:ea typeface="Calibri" pitchFamily="34" charset="-122"/>
-                <a:cs typeface="Calibri" pitchFamily="34" charset="-120"/>
-              </a:rPr>
-              <a:t>Entire subtrees pruned without expanding!</a:t>
-            </a:r>
-            <a:endParaRPr lang="en-US" sz="1200" dirty="0"/>
-          </a:p>
-        </p:txBody>
-      </p:sp>
-      <p:sp>
-        <p:nvSpPr>
-          <p:cNvPr id="12" name="Shape 10"/>
-          <p:cNvSpPr/>
-          <p:nvPr/>
-        </p:nvSpPr>
-        <p:spPr>
-          <a:xfrm>
-            <a:off x="6309360" y="2011680"/>
-            <a:ext cx="2377440" cy="3657600"/>
+            <a:endParaRPr lang="en-US" sz="1250" dirty="0"/>
+          </a:p>
+          <a:p>
+            <a:pPr indent="0" marL="0">
+              <a:buNone/>
+            </a:pPr>
+            <a:endParaRPr lang="en-US" sz="1250" dirty="0"/>
+          </a:p>
+          <a:p>
+            <a:pPr indent="0" marL="0">
+              <a:buNone/>
+            </a:pPr>
+            <a:r>
+              <a:rPr lang="en-US" sz="1250" dirty="0">
+                <a:solidFill>
+                  <a:srgbClr val="94A3B8"/>
+                </a:solidFill>
+                <a:latin typeface="Calibri" pitchFamily="34" charset="0"/>
+                <a:ea typeface="Calibri" pitchFamily="34" charset="-122"/>
+                <a:cs typeface="Calibri" pitchFamily="34" charset="-120"/>
+              </a:rPr>
+              <a:t>Entire subtree is pruned without expanding child nodes!</a:t>
+            </a:r>
+            <a:endParaRPr lang="en-US" sz="1250" dirty="0"/>
+          </a:p>
+        </p:txBody>
+      </p:sp>
+      <p:sp>
+        <p:nvSpPr>
+          <p:cNvPr id="11" name="Shape 9"/>
+          <p:cNvSpPr/>
+          <p:nvPr/>
+        </p:nvSpPr>
+        <p:spPr>
+          <a:xfrm>
+            <a:off x="6236208" y="1508760"/>
+            <a:ext cx="2468880" cy="4754880"/>
           </a:xfrm>
           <a:prstGeom prst="roundRect">
             <a:avLst>
-              <a:gd name="adj" fmla="val 3077"/>
+              <a:gd name="adj" fmla="val 2963"/>
             </a:avLst>
           </a:prstGeom>
           <a:solidFill>
-            <a:srgbClr val="0F172A"/>
+            <a:srgbClr val="1E293B"/>
           </a:solidFill>
-          <a:ln w="12700">
+          <a:ln w="19050">
             <a:solidFill>
               <a:srgbClr val="F59E0B"/>
             </a:solidFill>
@@ -5331,14 +5356,14 @@
       </p:sp>
       <p:sp>
         <p:nvSpPr>
-          <p:cNvPr id="13" name="Text 11"/>
-          <p:cNvSpPr/>
-          <p:nvPr/>
-        </p:nvSpPr>
-        <p:spPr>
-          <a:xfrm>
-            <a:off x="6400800" y="2194560"/>
-            <a:ext cx="2194560" cy="548640"/>
+          <p:cNvPr id="12" name="Text 10"/>
+          <p:cNvSpPr/>
+          <p:nvPr/>
+        </p:nvSpPr>
+        <p:spPr>
+          <a:xfrm>
+            <a:off x="6327648" y="1737360"/>
+            <a:ext cx="2286000" cy="548640"/>
           </a:xfrm>
           <a:prstGeom prst="rect">
             <a:avLst/>
@@ -5354,7 +5379,7 @@
               <a:buNone/>
             </a:pPr>
             <a:r>
-              <a:rPr lang="en-US" sz="1300" b="1" dirty="0">
+              <a:rPr lang="en-US" sz="1400" b="1" dirty="0">
                 <a:solidFill>
                   <a:srgbClr val="F59E0B"/>
                 </a:solidFill>
@@ -5364,14 +5389,14 @@
               </a:rPr>
               <a:t>STATE 3</a:t>
             </a:r>
-            <a:endParaRPr lang="en-US" sz="1300" dirty="0"/>
+            <a:endParaRPr lang="en-US" sz="1400" dirty="0"/>
           </a:p>
           <a:p>
             <a:pPr algn="ctr" indent="0" marL="0">
               <a:buNone/>
             </a:pPr>
             <a:r>
-              <a:rPr lang="en-US" sz="1300" b="1" dirty="0">
+              <a:rPr lang="en-US" sz="1400" b="1" dirty="0">
                 <a:solidFill>
                   <a:srgbClr val="F59E0B"/>
                 </a:solidFill>
@@ -5381,20 +5406,20 @@
               </a:rPr>
               <a:t>Dead-End Detection</a:t>
             </a:r>
-            <a:endParaRPr lang="en-US" sz="1300" dirty="0"/>
-          </a:p>
-        </p:txBody>
-      </p:sp>
-      <p:sp>
-        <p:nvSpPr>
-          <p:cNvPr id="14" name="Text 12"/>
-          <p:cNvSpPr/>
-          <p:nvPr/>
-        </p:nvSpPr>
-        <p:spPr>
-          <a:xfrm>
-            <a:off x="6400800" y="2834640"/>
-            <a:ext cx="2194560" cy="2560320"/>
+            <a:endParaRPr lang="en-US" sz="1400" dirty="0"/>
+          </a:p>
+        </p:txBody>
+      </p:sp>
+      <p:sp>
+        <p:nvSpPr>
+          <p:cNvPr id="13" name="Text 11"/>
+          <p:cNvSpPr/>
+          <p:nvPr/>
+        </p:nvSpPr>
+        <p:spPr>
+          <a:xfrm>
+            <a:off x="6373368" y="2514600"/>
+            <a:ext cx="2194560" cy="3474720"/>
           </a:xfrm>
           <a:prstGeom prst="rect">
             <a:avLst/>
@@ -5410,7 +5435,7 @@
               <a:buNone/>
             </a:pPr>
             <a:r>
-              <a:rPr lang="en-US" sz="1200" dirty="0">
+              <a:rPr lang="en-US" sz="1250" dirty="0">
                 <a:solidFill>
                   <a:srgbClr val="94A3B8"/>
                 </a:solidFill>
@@ -5420,20 +5445,20 @@
               </a:rPr>
               <a:t>Advance to Cell (0, 3)</a:t>
             </a:r>
-            <a:endParaRPr lang="en-US" sz="1200" dirty="0"/>
-          </a:p>
-          <a:p>
-            <a:pPr indent="0" marL="0">
-              <a:buNone/>
-            </a:pPr>
-            <a:endParaRPr lang="en-US" sz="1200" dirty="0"/>
-          </a:p>
-          <a:p>
-            <a:pPr indent="0" marL="0">
-              <a:buNone/>
-            </a:pPr>
-            <a:r>
-              <a:rPr lang="en-US" sz="1200" dirty="0">
+            <a:endParaRPr lang="en-US" sz="1250" dirty="0"/>
+          </a:p>
+          <a:p>
+            <a:pPr indent="0" marL="0">
+              <a:buNone/>
+            </a:pPr>
+            <a:endParaRPr lang="en-US" sz="1250" dirty="0"/>
+          </a:p>
+          <a:p>
+            <a:pPr indent="0" marL="0">
+              <a:buNone/>
+            </a:pPr>
+            <a:r>
+              <a:rPr lang="en-US" sz="1250" dirty="0">
                 <a:solidFill>
                   <a:srgbClr val="94A3B8"/>
                 </a:solidFill>
@@ -5443,20 +5468,20 @@
               </a:rPr>
               <a:t>Try 1..9 -&gt; All fail constraints!</a:t>
             </a:r>
-            <a:endParaRPr lang="en-US" sz="1200" dirty="0"/>
-          </a:p>
-          <a:p>
-            <a:pPr indent="0" marL="0">
-              <a:buNone/>
-            </a:pPr>
-            <a:endParaRPr lang="en-US" sz="1200" dirty="0"/>
-          </a:p>
-          <a:p>
-            <a:pPr indent="0" marL="0">
-              <a:buNone/>
-            </a:pPr>
-            <a:r>
-              <a:rPr lang="en-US" sz="1200" dirty="0">
+            <a:endParaRPr lang="en-US" sz="1250" dirty="0"/>
+          </a:p>
+          <a:p>
+            <a:pPr indent="0" marL="0">
+              <a:buNone/>
+            </a:pPr>
+            <a:endParaRPr lang="en-US" sz="1250" dirty="0"/>
+          </a:p>
+          <a:p>
+            <a:pPr indent="0" marL="0">
+              <a:buNone/>
+            </a:pPr>
+            <a:r>
+              <a:rPr lang="en-US" sz="1250" dirty="0">
                 <a:solidFill>
                   <a:srgbClr val="94A3B8"/>
                 </a:solidFill>
@@ -5466,47 +5491,53 @@
               </a:rPr>
               <a:t>No consistent value exists in domain.</a:t>
             </a:r>
-            <a:endParaRPr lang="en-US" sz="1200" dirty="0"/>
-          </a:p>
-          <a:p>
-            <a:pPr indent="0" marL="0">
-              <a:buNone/>
-            </a:pPr>
-            <a:r>
-              <a:rPr lang="en-US" sz="1200" dirty="0">
-                <a:solidFill>
-                  <a:srgbClr val="94A3B8"/>
-                </a:solidFill>
-                <a:latin typeface="Calibri" pitchFamily="34" charset="0"/>
-                <a:ea typeface="Calibri" pitchFamily="34" charset="-122"/>
-                <a:cs typeface="Calibri" pitchFamily="34" charset="-120"/>
-              </a:rPr>
-              <a:t>Dead-end encountered.</a:t>
-            </a:r>
-            <a:endParaRPr lang="en-US" sz="1200" dirty="0"/>
-          </a:p>
-        </p:txBody>
-      </p:sp>
-      <p:sp>
-        <p:nvSpPr>
-          <p:cNvPr id="15" name="Shape 13"/>
-          <p:cNvSpPr/>
-          <p:nvPr/>
-        </p:nvSpPr>
-        <p:spPr>
-          <a:xfrm>
-            <a:off x="8961120" y="2011680"/>
-            <a:ext cx="2377440" cy="3657600"/>
+            <a:endParaRPr lang="en-US" sz="1250" dirty="0"/>
+          </a:p>
+          <a:p>
+            <a:pPr indent="0" marL="0">
+              <a:buNone/>
+            </a:pPr>
+            <a:endParaRPr lang="en-US" sz="1250" dirty="0"/>
+          </a:p>
+          <a:p>
+            <a:pPr indent="0" marL="0">
+              <a:buNone/>
+            </a:pPr>
+            <a:r>
+              <a:rPr lang="en-US" sz="1250" dirty="0">
+                <a:solidFill>
+                  <a:srgbClr val="94A3B8"/>
+                </a:solidFill>
+                <a:latin typeface="Calibri" pitchFamily="34" charset="0"/>
+                <a:ea typeface="Calibri" pitchFamily="34" charset="-122"/>
+                <a:cs typeface="Calibri" pitchFamily="34" charset="-120"/>
+              </a:rPr>
+              <a:t>Dead-end encountered in search tree.</a:t>
+            </a:r>
+            <a:endParaRPr lang="en-US" sz="1250" dirty="0"/>
+          </a:p>
+        </p:txBody>
+      </p:sp>
+      <p:sp>
+        <p:nvSpPr>
+          <p:cNvPr id="14" name="Shape 12"/>
+          <p:cNvSpPr/>
+          <p:nvPr/>
+        </p:nvSpPr>
+        <p:spPr>
+          <a:xfrm>
+            <a:off x="8988552" y="1508760"/>
+            <a:ext cx="2468880" cy="4754880"/>
           </a:xfrm>
           <a:prstGeom prst="roundRect">
             <a:avLst>
-              <a:gd name="adj" fmla="val 3077"/>
+              <a:gd name="adj" fmla="val 2963"/>
             </a:avLst>
           </a:prstGeom>
           <a:solidFill>
-            <a:srgbClr val="0F172A"/>
+            <a:srgbClr val="1E293B"/>
           </a:solidFill>
-          <a:ln w="12700">
+          <a:ln w="19050">
             <a:solidFill>
               <a:srgbClr val="10B981"/>
             </a:solidFill>
@@ -5516,14 +5547,14 @@
       </p:sp>
       <p:sp>
         <p:nvSpPr>
-          <p:cNvPr id="16" name="Text 14"/>
-          <p:cNvSpPr/>
-          <p:nvPr/>
-        </p:nvSpPr>
-        <p:spPr>
-          <a:xfrm>
-            <a:off x="9052560" y="2194560"/>
-            <a:ext cx="2194560" cy="548640"/>
+          <p:cNvPr id="15" name="Text 13"/>
+          <p:cNvSpPr/>
+          <p:nvPr/>
+        </p:nvSpPr>
+        <p:spPr>
+          <a:xfrm>
+            <a:off x="9079992" y="1737360"/>
+            <a:ext cx="2286000" cy="548640"/>
           </a:xfrm>
           <a:prstGeom prst="rect">
             <a:avLst/>
@@ -5539,7 +5570,7 @@
               <a:buNone/>
             </a:pPr>
             <a:r>
-              <a:rPr lang="en-US" sz="1300" b="1" dirty="0">
+              <a:rPr lang="en-US" sz="1400" b="1" dirty="0">
                 <a:solidFill>
                   <a:srgbClr val="10B981"/>
                 </a:solidFill>
@@ -5549,14 +5580,14 @@
               </a:rPr>
               <a:t>STATE 4</a:t>
             </a:r>
-            <a:endParaRPr lang="en-US" sz="1300" dirty="0"/>
+            <a:endParaRPr lang="en-US" sz="1400" dirty="0"/>
           </a:p>
           <a:p>
             <a:pPr algn="ctr" indent="0" marL="0">
               <a:buNone/>
             </a:pPr>
             <a:r>
-              <a:rPr lang="en-US" sz="1300" b="1" dirty="0">
+              <a:rPr lang="en-US" sz="1400" b="1" dirty="0">
                 <a:solidFill>
                   <a:srgbClr val="10B981"/>
                 </a:solidFill>
@@ -5566,20 +5597,20 @@
               </a:rPr>
               <a:t>Backtracking Recovery</a:t>
             </a:r>
-            <a:endParaRPr lang="en-US" sz="1300" dirty="0"/>
-          </a:p>
-        </p:txBody>
-      </p:sp>
-      <p:sp>
-        <p:nvSpPr>
-          <p:cNvPr id="17" name="Text 15"/>
-          <p:cNvSpPr/>
-          <p:nvPr/>
-        </p:nvSpPr>
-        <p:spPr>
-          <a:xfrm>
-            <a:off x="9052560" y="2834640"/>
-            <a:ext cx="2194560" cy="2560320"/>
+            <a:endParaRPr lang="en-US" sz="1400" dirty="0"/>
+          </a:p>
+        </p:txBody>
+      </p:sp>
+      <p:sp>
+        <p:nvSpPr>
+          <p:cNvPr id="16" name="Text 14"/>
+          <p:cNvSpPr/>
+          <p:nvPr/>
+        </p:nvSpPr>
+        <p:spPr>
+          <a:xfrm>
+            <a:off x="9125712" y="2514600"/>
+            <a:ext cx="2194560" cy="3474720"/>
           </a:xfrm>
           <a:prstGeom prst="rect">
             <a:avLst/>
@@ -5595,24 +5626,24 @@
               <a:buNone/>
             </a:pPr>
             <a:r>
-              <a:rPr lang="en-US" sz="1200" dirty="0">
-                <a:solidFill>
-                  <a:srgbClr val="94A3B8"/>
-                </a:solidFill>
-                <a:latin typeface="Calibri" pitchFamily="34" charset="0"/>
-                <a:ea typeface="Calibri" pitchFamily="34" charset="-122"/>
-                <a:cs typeface="Calibri" pitchFamily="34" charset="-120"/>
-              </a:rPr>
-              <a:t>Unwind recursion:</a:t>
-            </a:r>
-            <a:endParaRPr lang="en-US" sz="1200" dirty="0"/>
-          </a:p>
-          <a:p>
-            <a:pPr indent="0" marL="0">
-              <a:buNone/>
-            </a:pPr>
-            <a:r>
-              <a:rPr lang="en-US" sz="1200" dirty="0">
+              <a:rPr lang="en-US" sz="1250" dirty="0">
+                <a:solidFill>
+                  <a:srgbClr val="94A3B8"/>
+                </a:solidFill>
+                <a:latin typeface="Calibri" pitchFamily="34" charset="0"/>
+                <a:ea typeface="Calibri" pitchFamily="34" charset="-122"/>
+                <a:cs typeface="Calibri" pitchFamily="34" charset="-120"/>
+              </a:rPr>
+              <a:t>Unwind recursion stack:</a:t>
+            </a:r>
+            <a:endParaRPr lang="en-US" sz="1250" dirty="0"/>
+          </a:p>
+          <a:p>
+            <a:pPr indent="0" marL="0">
+              <a:buNone/>
+            </a:pPr>
+            <a:r>
+              <a:rPr lang="en-US" sz="1250" dirty="0">
                 <a:solidFill>
                   <a:srgbClr val="94A3B8"/>
                 </a:solidFill>
@@ -5622,20 +5653,20 @@
               </a:rPr>
               <a:t>Reset (0, 2) = 0</a:t>
             </a:r>
-            <a:endParaRPr lang="en-US" sz="1200" dirty="0"/>
-          </a:p>
-          <a:p>
-            <a:pPr indent="0" marL="0">
-              <a:buNone/>
-            </a:pPr>
-            <a:endParaRPr lang="en-US" sz="1200" dirty="0"/>
-          </a:p>
-          <a:p>
-            <a:pPr indent="0" marL="0">
-              <a:buNone/>
-            </a:pPr>
-            <a:r>
-              <a:rPr lang="en-US" sz="1200" dirty="0">
+            <a:endParaRPr lang="en-US" sz="1250" dirty="0"/>
+          </a:p>
+          <a:p>
+            <a:pPr indent="0" marL="0">
+              <a:buNone/>
+            </a:pPr>
+            <a:endParaRPr lang="en-US" sz="1250" dirty="0"/>
+          </a:p>
+          <a:p>
+            <a:pPr indent="0" marL="0">
+              <a:buNone/>
+            </a:pPr>
+            <a:r>
+              <a:rPr lang="en-US" sz="1250" dirty="0">
                 <a:solidFill>
                   <a:srgbClr val="94A3B8"/>
                 </a:solidFill>
@@ -5645,20 +5676,20 @@
               </a:rPr>
               <a:t>Try next candidate (e.g. 7)</a:t>
             </a:r>
-            <a:endParaRPr lang="en-US" sz="1200" dirty="0"/>
-          </a:p>
-          <a:p>
-            <a:pPr indent="0" marL="0">
-              <a:buNone/>
-            </a:pPr>
-            <a:endParaRPr lang="en-US" sz="1200" dirty="0"/>
-          </a:p>
-          <a:p>
-            <a:pPr indent="0" marL="0">
-              <a:buNone/>
-            </a:pPr>
-            <a:r>
-              <a:rPr lang="en-US" sz="1200" dirty="0">
+            <a:endParaRPr lang="en-US" sz="1250" dirty="0"/>
+          </a:p>
+          <a:p>
+            <a:pPr indent="0" marL="0">
+              <a:buNone/>
+            </a:pPr>
+            <a:endParaRPr lang="en-US" sz="1250" dirty="0"/>
+          </a:p>
+          <a:p>
+            <a:pPr indent="0" marL="0">
+              <a:buNone/>
+            </a:pPr>
+            <a:r>
+              <a:rPr lang="en-US" sz="1250" dirty="0">
                 <a:solidFill>
                   <a:srgbClr val="94A3B8"/>
                 </a:solidFill>
@@ -5668,7 +5699,7 @@
               </a:rPr>
               <a:t>Search continues until all 81 variables satisfy all constraints.</a:t>
             </a:r>
-            <a:endParaRPr lang="en-US" sz="1200" dirty="0"/>
+            <a:endParaRPr lang="en-US" sz="1250" dirty="0"/>
           </a:p>
         </p:txBody>
       </p:sp>
@@ -5712,8 +5743,8 @@
         </p:nvSpPr>
         <p:spPr>
           <a:xfrm>
-            <a:off x="731520" y="457200"/>
-            <a:ext cx="7315200" cy="274320"/>
+            <a:off x="731520" y="411480"/>
+            <a:ext cx="9144000" cy="274320"/>
           </a:xfrm>
           <a:prstGeom prst="rect">
             <a:avLst/>
@@ -5751,8 +5782,8 @@
         </p:nvSpPr>
         <p:spPr>
           <a:xfrm>
-            <a:off x="731520" y="731520"/>
-            <a:ext cx="10515600" cy="640080"/>
+            <a:off x="731520" y="685800"/>
+            <a:ext cx="10698480" cy="548640"/>
           </a:xfrm>
           <a:prstGeom prst="rect">
             <a:avLst/>
@@ -5768,7 +5799,7 @@
               <a:buNone/>
             </a:pPr>
             <a:r>
-              <a:rPr lang="en-US" sz="2400" b="1" dirty="0">
+              <a:rPr lang="en-US" sz="2200" b="1" dirty="0">
                 <a:solidFill>
                   <a:srgbClr val="FFFFFF"/>
                 </a:solidFill>
@@ -5778,7 +5809,7 @@
               </a:rPr>
               <a:t>Enhancing CSP: Variable &amp; Value Ordering</a:t>
             </a:r>
-            <a:endParaRPr lang="en-US" sz="2400" dirty="0"/>
+            <a:endParaRPr lang="en-US" sz="2200" dirty="0"/>
           </a:p>
         </p:txBody>
       </p:sp>
@@ -5790,8 +5821,8 @@
         </p:nvSpPr>
         <p:spPr>
           <a:xfrm>
-            <a:off x="731520" y="1417320"/>
-            <a:ext cx="10698480" cy="18288"/>
+            <a:off x="731520" y="1298448"/>
+            <a:ext cx="10725912" cy="18288"/>
           </a:xfrm>
           <a:prstGeom prst="rect">
             <a:avLst/>
@@ -5815,12 +5846,12 @@
         </p:nvSpPr>
         <p:spPr>
           <a:xfrm>
-            <a:off x="731520" y="1645920"/>
-            <a:ext cx="5120640" cy="2057400"/>
+            <a:off x="731520" y="1508760"/>
+            <a:ext cx="5212080" cy="2240280"/>
           </a:xfrm>
           <a:prstGeom prst="roundRect">
             <a:avLst>
-              <a:gd name="adj" fmla="val 4444"/>
+              <a:gd name="adj" fmla="val 4082"/>
             </a:avLst>
           </a:prstGeom>
           <a:solidFill>
@@ -5842,7 +5873,7 @@
         </p:nvSpPr>
         <p:spPr>
           <a:xfrm>
-            <a:off x="914400" y="1783080"/>
+            <a:off x="960120" y="1645920"/>
             <a:ext cx="4754880" cy="320040"/>
           </a:xfrm>
           <a:prstGeom prst="rect">
@@ -5859,7 +5890,7 @@
               <a:buNone/>
             </a:pPr>
             <a:r>
-              <a:rPr lang="en-US" sz="1400" b="1" dirty="0">
+              <a:rPr lang="en-US" sz="1500" b="1" dirty="0">
                 <a:solidFill>
                   <a:srgbClr val="38BDF8"/>
                 </a:solidFill>
@@ -5869,7 +5900,7 @@
               </a:rPr>
               <a:t>MRV (Minimum Remaining Values)</a:t>
             </a:r>
-            <a:endParaRPr lang="en-US" sz="1400" dirty="0"/>
+            <a:endParaRPr lang="en-US" sz="1500" dirty="0"/>
           </a:p>
         </p:txBody>
       </p:sp>
@@ -5881,8 +5912,8 @@
         </p:nvSpPr>
         <p:spPr>
           <a:xfrm>
-            <a:off x="914400" y="2148840"/>
-            <a:ext cx="4754880" cy="1371600"/>
+            <a:off x="960120" y="2011680"/>
+            <a:ext cx="4754880" cy="1554480"/>
           </a:xfrm>
           <a:prstGeom prst="rect">
             <a:avLst/>
@@ -5898,24 +5929,24 @@
               <a:buNone/>
             </a:pPr>
             <a:r>
-              <a:rPr lang="en-US" sz="1200" dirty="0">
-                <a:solidFill>
-                  <a:srgbClr val="94A3B8"/>
-                </a:solidFill>
-                <a:latin typeface="Calibri" pitchFamily="34" charset="0"/>
-                <a:ea typeface="Calibri" pitchFamily="34" charset="-122"/>
-                <a:cs typeface="Calibri" pitchFamily="34" charset="-120"/>
-              </a:rPr>
-              <a:t>• Concept: Choose the variable with the fewest legal values in its domain.</a:t>
-            </a:r>
-            <a:endParaRPr lang="en-US" sz="1200" dirty="0"/>
-          </a:p>
-          <a:p>
-            <a:pPr indent="0" marL="0">
-              <a:buNone/>
-            </a:pPr>
-            <a:r>
-              <a:rPr lang="en-US" sz="1200" dirty="0">
+              <a:rPr lang="en-US" sz="1250" dirty="0">
+                <a:solidFill>
+                  <a:srgbClr val="94A3B8"/>
+                </a:solidFill>
+                <a:latin typeface="Calibri" pitchFamily="34" charset="0"/>
+                <a:ea typeface="Calibri" pitchFamily="34" charset="-122"/>
+                <a:cs typeface="Calibri" pitchFamily="34" charset="-120"/>
+              </a:rPr>
+              <a:t>• Concept: Choose the variable with fewest legal values left in its domain.</a:t>
+            </a:r>
+            <a:endParaRPr lang="en-US" sz="1250" dirty="0"/>
+          </a:p>
+          <a:p>
+            <a:pPr indent="0" marL="0">
+              <a:buNone/>
+            </a:pPr>
+            <a:r>
+              <a:rPr lang="en-US" sz="1250" dirty="0">
                 <a:solidFill>
                   <a:srgbClr val="94A3B8"/>
                 </a:solidFill>
@@ -5925,24 +5956,24 @@
               </a:rPr>
               <a:t>• Also known as: Most Constrained Variable or 'Fail-First' heuristic.</a:t>
             </a:r>
-            <a:endParaRPr lang="en-US" sz="1200" dirty="0"/>
-          </a:p>
-          <a:p>
-            <a:pPr indent="0" marL="0">
-              <a:buNone/>
-            </a:pPr>
-            <a:r>
-              <a:rPr lang="en-US" sz="1200" dirty="0">
-                <a:solidFill>
-                  <a:srgbClr val="94A3B8"/>
-                </a:solidFill>
-                <a:latin typeface="Calibri" pitchFamily="34" charset="0"/>
-                <a:ea typeface="Calibri" pitchFamily="34" charset="-122"/>
-                <a:cs typeface="Calibri" pitchFamily="34" charset="-120"/>
-              </a:rPr>
-              <a:t>• Benefit: Maximizes chances of detecting failure as high up in the tree as possible.</a:t>
-            </a:r>
-            <a:endParaRPr lang="en-US" sz="1200" dirty="0"/>
+            <a:endParaRPr lang="en-US" sz="1250" dirty="0"/>
+          </a:p>
+          <a:p>
+            <a:pPr indent="0" marL="0">
+              <a:buNone/>
+            </a:pPr>
+            <a:r>
+              <a:rPr lang="en-US" sz="1250" dirty="0">
+                <a:solidFill>
+                  <a:srgbClr val="94A3B8"/>
+                </a:solidFill>
+                <a:latin typeface="Calibri" pitchFamily="34" charset="0"/>
+                <a:ea typeface="Calibri" pitchFamily="34" charset="-122"/>
+                <a:cs typeface="Calibri" pitchFamily="34" charset="-120"/>
+              </a:rPr>
+              <a:t>• Benefit: Maximizes chances of detecting failure early, pruning high up.</a:t>
+            </a:r>
+            <a:endParaRPr lang="en-US" sz="1250" dirty="0"/>
           </a:p>
         </p:txBody>
       </p:sp>
@@ -5954,12 +5985,12 @@
         </p:nvSpPr>
         <p:spPr>
           <a:xfrm>
-            <a:off x="6217920" y="1645920"/>
-            <a:ext cx="5120640" cy="2057400"/>
+            <a:off x="6245352" y="1508760"/>
+            <a:ext cx="5212080" cy="2240280"/>
           </a:xfrm>
           <a:prstGeom prst="roundRect">
             <a:avLst>
-              <a:gd name="adj" fmla="val 4444"/>
+              <a:gd name="adj" fmla="val 4082"/>
             </a:avLst>
           </a:prstGeom>
           <a:solidFill>
@@ -5981,7 +6012,7 @@
         </p:nvSpPr>
         <p:spPr>
           <a:xfrm>
-            <a:off x="6400800" y="1783080"/>
+            <a:off x="6473952" y="1645920"/>
             <a:ext cx="4754880" cy="320040"/>
           </a:xfrm>
           <a:prstGeom prst="rect">
@@ -5998,7 +6029,7 @@
               <a:buNone/>
             </a:pPr>
             <a:r>
-              <a:rPr lang="en-US" sz="1400" b="1" dirty="0">
+              <a:rPr lang="en-US" sz="1500" b="1" dirty="0">
                 <a:solidFill>
                   <a:srgbClr val="6366F1"/>
                 </a:solidFill>
@@ -6008,7 +6039,7 @@
               </a:rPr>
               <a:t>Degree Heuristic (Tie-Breaker)</a:t>
             </a:r>
-            <a:endParaRPr lang="en-US" sz="1400" dirty="0"/>
+            <a:endParaRPr lang="en-US" sz="1500" dirty="0"/>
           </a:p>
         </p:txBody>
       </p:sp>
@@ -6020,8 +6051,8 @@
         </p:nvSpPr>
         <p:spPr>
           <a:xfrm>
-            <a:off x="6400800" y="2148840"/>
-            <a:ext cx="4754880" cy="1371600"/>
+            <a:off x="6473952" y="2011680"/>
+            <a:ext cx="4754880" cy="1554480"/>
           </a:xfrm>
           <a:prstGeom prst="rect">
             <a:avLst/>
@@ -6037,41 +6068,41 @@
               <a:buNone/>
             </a:pPr>
             <a:r>
-              <a:rPr lang="en-US" sz="1200" dirty="0">
-                <a:solidFill>
-                  <a:srgbClr val="94A3B8"/>
-                </a:solidFill>
-                <a:latin typeface="Calibri" pitchFamily="34" charset="0"/>
-                <a:ea typeface="Calibri" pitchFamily="34" charset="-122"/>
-                <a:cs typeface="Calibri" pitchFamily="34" charset="-120"/>
-              </a:rPr>
-              <a:t>• Concept: Select the variable involved in the most constraints on unassigned variables.</a:t>
-            </a:r>
-            <a:endParaRPr lang="en-US" sz="1200" dirty="0"/>
-          </a:p>
-          <a:p>
-            <a:pPr indent="0" marL="0">
-              <a:buNone/>
-            </a:pPr>
-            <a:r>
-              <a:rPr lang="en-US" sz="1200" dirty="0">
-                <a:solidFill>
-                  <a:srgbClr val="94A3B8"/>
-                </a:solidFill>
-                <a:latin typeface="Calibri" pitchFamily="34" charset="0"/>
-                <a:ea typeface="Calibri" pitchFamily="34" charset="-122"/>
-                <a:cs typeface="Calibri" pitchFamily="34" charset="-120"/>
-              </a:rPr>
-              <a:t>• Application: Used as a tie-breaker when multiple cells share the same MRV count.</a:t>
-            </a:r>
-            <a:endParaRPr lang="en-US" sz="1200" dirty="0"/>
-          </a:p>
-          <a:p>
-            <a:pPr indent="0" marL="0">
-              <a:buNone/>
-            </a:pPr>
-            <a:r>
-              <a:rPr lang="en-US" sz="1200" dirty="0">
+              <a:rPr lang="en-US" sz="1250" dirty="0">
+                <a:solidFill>
+                  <a:srgbClr val="94A3B8"/>
+                </a:solidFill>
+                <a:latin typeface="Calibri" pitchFamily="34" charset="0"/>
+                <a:ea typeface="Calibri" pitchFamily="34" charset="-122"/>
+                <a:cs typeface="Calibri" pitchFamily="34" charset="-120"/>
+              </a:rPr>
+              <a:t>• Concept: Select variable involved in most constraints on unassigned variables.</a:t>
+            </a:r>
+            <a:endParaRPr lang="en-US" sz="1250" dirty="0"/>
+          </a:p>
+          <a:p>
+            <a:pPr indent="0" marL="0">
+              <a:buNone/>
+            </a:pPr>
+            <a:r>
+              <a:rPr lang="en-US" sz="1250" dirty="0">
+                <a:solidFill>
+                  <a:srgbClr val="94A3B8"/>
+                </a:solidFill>
+                <a:latin typeface="Calibri" pitchFamily="34" charset="0"/>
+                <a:ea typeface="Calibri" pitchFamily="34" charset="-122"/>
+                <a:cs typeface="Calibri" pitchFamily="34" charset="-120"/>
+              </a:rPr>
+              <a:t>• Application: Used as tie-breaker when multiple cells share the same MRV count.</a:t>
+            </a:r>
+            <a:endParaRPr lang="en-US" sz="1250" dirty="0"/>
+          </a:p>
+          <a:p>
+            <a:pPr indent="0" marL="0">
+              <a:buNone/>
+            </a:pPr>
+            <a:r>
+              <a:rPr lang="en-US" sz="1250" dirty="0">
                 <a:solidFill>
                   <a:srgbClr val="94A3B8"/>
                 </a:solidFill>
@@ -6081,7 +6112,7 @@
               </a:rPr>
               <a:t>• Benefit: Imposes constraints on the largest number of remaining variables.</a:t>
             </a:r>
-            <a:endParaRPr lang="en-US" sz="1200" dirty="0"/>
+            <a:endParaRPr lang="en-US" sz="1250" dirty="0"/>
           </a:p>
         </p:txBody>
       </p:sp>
@@ -6093,12 +6124,12 @@
         </p:nvSpPr>
         <p:spPr>
           <a:xfrm>
-            <a:off x="731520" y="3931920"/>
-            <a:ext cx="5120640" cy="2057400"/>
+            <a:off x="731520" y="4023360"/>
+            <a:ext cx="5212080" cy="2240280"/>
           </a:xfrm>
           <a:prstGeom prst="roundRect">
             <a:avLst>
-              <a:gd name="adj" fmla="val 4444"/>
+              <a:gd name="adj" fmla="val 4082"/>
             </a:avLst>
           </a:prstGeom>
           <a:solidFill>
@@ -6120,7 +6151,7 @@
         </p:nvSpPr>
         <p:spPr>
           <a:xfrm>
-            <a:off x="914400" y="4069080"/>
+            <a:off x="960120" y="4160520"/>
             <a:ext cx="4754880" cy="320040"/>
           </a:xfrm>
           <a:prstGeom prst="rect">
@@ -6137,7 +6168,7 @@
               <a:buNone/>
             </a:pPr>
             <a:r>
-              <a:rPr lang="en-US" sz="1400" b="1" dirty="0">
+              <a:rPr lang="en-US" sz="1500" b="1" dirty="0">
                 <a:solidFill>
                   <a:srgbClr val="10B981"/>
                 </a:solidFill>
@@ -6147,7 +6178,7 @@
               </a:rPr>
               <a:t>LCV (Least Constraining Value)</a:t>
             </a:r>
-            <a:endParaRPr lang="en-US" sz="1400" dirty="0"/>
+            <a:endParaRPr lang="en-US" sz="1500" dirty="0"/>
           </a:p>
         </p:txBody>
       </p:sp>
@@ -6159,8 +6190,8 @@
         </p:nvSpPr>
         <p:spPr>
           <a:xfrm>
-            <a:off x="914400" y="4434840"/>
-            <a:ext cx="4754880" cy="1371600"/>
+            <a:off x="960120" y="4526280"/>
+            <a:ext cx="4754880" cy="1554480"/>
           </a:xfrm>
           <a:prstGeom prst="rect">
             <a:avLst/>
@@ -6176,41 +6207,41 @@
               <a:buNone/>
             </a:pPr>
             <a:r>
-              <a:rPr lang="en-US" sz="1200" dirty="0">
-                <a:solidFill>
-                  <a:srgbClr val="94A3B8"/>
-                </a:solidFill>
-                <a:latin typeface="Calibri" pitchFamily="34" charset="0"/>
-                <a:ea typeface="Calibri" pitchFamily="34" charset="-122"/>
-                <a:cs typeface="Calibri" pitchFamily="34" charset="-120"/>
-              </a:rPr>
-              <a:t>• Concept: Given a variable, choose the value that rules out the fewest choices for neighbors.</a:t>
-            </a:r>
-            <a:endParaRPr lang="en-US" sz="1200" dirty="0"/>
-          </a:p>
-          <a:p>
-            <a:pPr indent="0" marL="0">
-              <a:buNone/>
-            </a:pPr>
-            <a:r>
-              <a:rPr lang="en-US" sz="1200" dirty="0">
-                <a:solidFill>
-                  <a:srgbClr val="94A3B8"/>
-                </a:solidFill>
-                <a:latin typeface="Calibri" pitchFamily="34" charset="0"/>
-                <a:ea typeface="Calibri" pitchFamily="34" charset="-122"/>
-                <a:cs typeface="Calibri" pitchFamily="34" charset="-120"/>
-              </a:rPr>
-              <a:t>• Principle: 'Fail-Last' heuristic; leaves maximum flexibility for subsequent variables.</a:t>
-            </a:r>
-            <a:endParaRPr lang="en-US" sz="1200" dirty="0"/>
-          </a:p>
-          <a:p>
-            <a:pPr indent="0" marL="0">
-              <a:buNone/>
-            </a:pPr>
-            <a:r>
-              <a:rPr lang="en-US" sz="1200" dirty="0">
+              <a:rPr lang="en-US" sz="1250" dirty="0">
+                <a:solidFill>
+                  <a:srgbClr val="94A3B8"/>
+                </a:solidFill>
+                <a:latin typeface="Calibri" pitchFamily="34" charset="0"/>
+                <a:ea typeface="Calibri" pitchFamily="34" charset="-122"/>
+                <a:cs typeface="Calibri" pitchFamily="34" charset="-120"/>
+              </a:rPr>
+              <a:t>• Concept: Choose the value that rules out fewest choices for neighbors.</a:t>
+            </a:r>
+            <a:endParaRPr lang="en-US" sz="1250" dirty="0"/>
+          </a:p>
+          <a:p>
+            <a:pPr indent="0" marL="0">
+              <a:buNone/>
+            </a:pPr>
+            <a:r>
+              <a:rPr lang="en-US" sz="1250" dirty="0">
+                <a:solidFill>
+                  <a:srgbClr val="94A3B8"/>
+                </a:solidFill>
+                <a:latin typeface="Calibri" pitchFamily="34" charset="0"/>
+                <a:ea typeface="Calibri" pitchFamily="34" charset="-122"/>
+                <a:cs typeface="Calibri" pitchFamily="34" charset="-120"/>
+              </a:rPr>
+              <a:t>• Principle: 'Fail-Last' heuristic; leaves maximum flexibility for subsequent steps.</a:t>
+            </a:r>
+            <a:endParaRPr lang="en-US" sz="1250" dirty="0"/>
+          </a:p>
+          <a:p>
+            <a:pPr indent="0" marL="0">
+              <a:buNone/>
+            </a:pPr>
+            <a:r>
+              <a:rPr lang="en-US" sz="1250" dirty="0">
                 <a:solidFill>
                   <a:srgbClr val="94A3B8"/>
                 </a:solidFill>
@@ -6220,7 +6251,7 @@
               </a:rPr>
               <a:t>• Benefit: Increases probability of reaching a valid solution on the first try.</a:t>
             </a:r>
-            <a:endParaRPr lang="en-US" sz="1200" dirty="0"/>
+            <a:endParaRPr lang="en-US" sz="1250" dirty="0"/>
           </a:p>
         </p:txBody>
       </p:sp>
@@ -6232,12 +6263,12 @@
         </p:nvSpPr>
         <p:spPr>
           <a:xfrm>
-            <a:off x="6217920" y="3931920"/>
-            <a:ext cx="5120640" cy="2057400"/>
+            <a:off x="6245352" y="4023360"/>
+            <a:ext cx="5212080" cy="2240280"/>
           </a:xfrm>
           <a:prstGeom prst="roundRect">
             <a:avLst>
-              <a:gd name="adj" fmla="val 4444"/>
+              <a:gd name="adj" fmla="val 4082"/>
             </a:avLst>
           </a:prstGeom>
           <a:solidFill>
@@ -6259,7 +6290,7 @@
         </p:nvSpPr>
         <p:spPr>
           <a:xfrm>
-            <a:off x="6400800" y="4069080"/>
+            <a:off x="6473952" y="4160520"/>
             <a:ext cx="4754880" cy="320040"/>
           </a:xfrm>
           <a:prstGeom prst="rect">
@@ -6276,7 +6307,7 @@
               <a:buNone/>
             </a:pPr>
             <a:r>
-              <a:rPr lang="en-US" sz="1400" b="1" dirty="0">
+              <a:rPr lang="en-US" sz="1500" b="1" dirty="0">
                 <a:solidFill>
                   <a:srgbClr val="F59E0B"/>
                 </a:solidFill>
@@ -6286,7 +6317,7 @@
               </a:rPr>
               <a:t>Forward Checking &amp; AC-3 (Arc Consistency)</a:t>
             </a:r>
-            <a:endParaRPr lang="en-US" sz="1400" dirty="0"/>
+            <a:endParaRPr lang="en-US" sz="1500" dirty="0"/>
           </a:p>
         </p:txBody>
       </p:sp>
@@ -6298,8 +6329,8 @@
         </p:nvSpPr>
         <p:spPr>
           <a:xfrm>
-            <a:off x="6400800" y="4434840"/>
-            <a:ext cx="4754880" cy="1371600"/>
+            <a:off x="6473952" y="4526280"/>
+            <a:ext cx="4754880" cy="1554480"/>
           </a:xfrm>
           <a:prstGeom prst="rect">
             <a:avLst/>
@@ -6315,51 +6346,51 @@
               <a:buNone/>
             </a:pPr>
             <a:r>
-              <a:rPr lang="en-US" sz="1200" dirty="0">
-                <a:solidFill>
-                  <a:srgbClr val="94A3B8"/>
-                </a:solidFill>
-                <a:latin typeface="Calibri" pitchFamily="34" charset="0"/>
-                <a:ea typeface="Calibri" pitchFamily="34" charset="-122"/>
-                <a:cs typeface="Calibri" pitchFamily="34" charset="-120"/>
-              </a:rPr>
-              <a:t>• Forward Checking: Tracks domains of unassigned neighbors, pruning invalid values.</a:t>
-            </a:r>
-            <a:endParaRPr lang="en-US" sz="1200" dirty="0"/>
-          </a:p>
-          <a:p>
-            <a:pPr indent="0" marL="0">
-              <a:buNone/>
-            </a:pPr>
-            <a:r>
-              <a:rPr lang="en-US" sz="1200" dirty="0">
-                <a:solidFill>
-                  <a:srgbClr val="94A3B8"/>
-                </a:solidFill>
-                <a:latin typeface="Calibri" pitchFamily="34" charset="0"/>
-                <a:ea typeface="Calibri" pitchFamily="34" charset="-122"/>
-                <a:cs typeface="Calibri" pitchFamily="34" charset="-120"/>
-              </a:rPr>
-              <a:t>• AC-3 Algorithm: Enforces pairwise consistency across all 810 arcs in the constraint network.</a:t>
-            </a:r>
-            <a:endParaRPr lang="en-US" sz="1200" dirty="0"/>
-          </a:p>
-          <a:p>
-            <a:pPr indent="0" marL="0">
-              <a:buNone/>
-            </a:pPr>
-            <a:r>
-              <a:rPr lang="en-US" sz="1200" dirty="0">
-                <a:solidFill>
-                  <a:srgbClr val="94A3B8"/>
-                </a:solidFill>
-                <a:latin typeface="Calibri" pitchFamily="34" charset="0"/>
-                <a:ea typeface="Calibri" pitchFamily="34" charset="-122"/>
-                <a:cs typeface="Calibri" pitchFamily="34" charset="-120"/>
-              </a:rPr>
-              <a:t>• Result: Frequently solves easy/medium puzzles through propagation alone, with 0 backtracking.</a:t>
-            </a:r>
-            <a:endParaRPr lang="en-US" sz="1200" dirty="0"/>
+              <a:rPr lang="en-US" sz="1250" dirty="0">
+                <a:solidFill>
+                  <a:srgbClr val="94A3B8"/>
+                </a:solidFill>
+                <a:latin typeface="Calibri" pitchFamily="34" charset="0"/>
+                <a:ea typeface="Calibri" pitchFamily="34" charset="-122"/>
+                <a:cs typeface="Calibri" pitchFamily="34" charset="-120"/>
+              </a:rPr>
+              <a:t>• Forward Checking: Tracks neighbor domains, pruning invalid values immediately.</a:t>
+            </a:r>
+            <a:endParaRPr lang="en-US" sz="1250" dirty="0"/>
+          </a:p>
+          <a:p>
+            <a:pPr indent="0" marL="0">
+              <a:buNone/>
+            </a:pPr>
+            <a:r>
+              <a:rPr lang="en-US" sz="1250" dirty="0">
+                <a:solidFill>
+                  <a:srgbClr val="94A3B8"/>
+                </a:solidFill>
+                <a:latin typeface="Calibri" pitchFamily="34" charset="0"/>
+                <a:ea typeface="Calibri" pitchFamily="34" charset="-122"/>
+                <a:cs typeface="Calibri" pitchFamily="34" charset="-120"/>
+              </a:rPr>
+              <a:t>• AC-3 Algorithm: Enforces pairwise consistency across all 810 arcs in the network.</a:t>
+            </a:r>
+            <a:endParaRPr lang="en-US" sz="1250" dirty="0"/>
+          </a:p>
+          <a:p>
+            <a:pPr indent="0" marL="0">
+              <a:buNone/>
+            </a:pPr>
+            <a:r>
+              <a:rPr lang="en-US" sz="1250" dirty="0">
+                <a:solidFill>
+                  <a:srgbClr val="94A3B8"/>
+                </a:solidFill>
+                <a:latin typeface="Calibri" pitchFamily="34" charset="0"/>
+                <a:ea typeface="Calibri" pitchFamily="34" charset="-122"/>
+                <a:cs typeface="Calibri" pitchFamily="34" charset="-120"/>
+              </a:rPr>
+              <a:t>• Result: Solves many easy/medium puzzles via propagation alone with 0 backtracking.</a:t>
+            </a:r>
+            <a:endParaRPr lang="en-US" sz="1250" dirty="0"/>
           </a:p>
         </p:txBody>
       </p:sp>
@@ -6403,8 +6434,8 @@
         </p:nvSpPr>
         <p:spPr>
           <a:xfrm>
-            <a:off x="731520" y="457200"/>
-            <a:ext cx="7315200" cy="274320"/>
+            <a:off x="731520" y="411480"/>
+            <a:ext cx="9144000" cy="274320"/>
           </a:xfrm>
           <a:prstGeom prst="rect">
             <a:avLst/>
@@ -6442,8 +6473,8 @@
         </p:nvSpPr>
         <p:spPr>
           <a:xfrm>
-            <a:off x="731520" y="731520"/>
-            <a:ext cx="10515600" cy="640080"/>
+            <a:off x="731520" y="685800"/>
+            <a:ext cx="10698480" cy="548640"/>
           </a:xfrm>
           <a:prstGeom prst="rect">
             <a:avLst/>
@@ -6459,7 +6490,7 @@
               <a:buNone/>
             </a:pPr>
             <a:r>
-              <a:rPr lang="en-US" sz="2400" b="1" dirty="0">
+              <a:rPr lang="en-US" sz="2200" b="1" dirty="0">
                 <a:solidFill>
                   <a:srgbClr val="FFFFFF"/>
                 </a:solidFill>
@@ -6469,7 +6500,7 @@
               </a:rPr>
               <a:t>Interactive Web Application (React + Vite)</a:t>
             </a:r>
-            <a:endParaRPr lang="en-US" sz="2400" dirty="0"/>
+            <a:endParaRPr lang="en-US" sz="2200" dirty="0"/>
           </a:p>
         </p:txBody>
       </p:sp>
@@ -6481,8 +6512,8 @@
         </p:nvSpPr>
         <p:spPr>
           <a:xfrm>
-            <a:off x="731520" y="1417320"/>
-            <a:ext cx="10698480" cy="18288"/>
+            <a:off x="731520" y="1298448"/>
+            <a:ext cx="10725912" cy="18288"/>
           </a:xfrm>
           <a:prstGeom prst="rect">
             <a:avLst/>
@@ -6506,12 +6537,12 @@
         </p:nvSpPr>
         <p:spPr>
           <a:xfrm>
-            <a:off x="731520" y="1645920"/>
-            <a:ext cx="5120640" cy="4389120"/>
+            <a:off x="731520" y="1508760"/>
+            <a:ext cx="5212080" cy="4754880"/>
           </a:xfrm>
           <a:prstGeom prst="roundRect">
             <a:avLst>
-              <a:gd name="adj" fmla="val 2083"/>
+              <a:gd name="adj" fmla="val 1923"/>
             </a:avLst>
           </a:prstGeom>
           <a:solidFill>
@@ -6533,8 +6564,8 @@
         </p:nvSpPr>
         <p:spPr>
           <a:xfrm>
-            <a:off x="1005840" y="1828800"/>
-            <a:ext cx="4572000" cy="365760"/>
+            <a:off x="1005840" y="1737360"/>
+            <a:ext cx="4663440" cy="365760"/>
           </a:xfrm>
           <a:prstGeom prst="rect">
             <a:avLst/>
@@ -6572,8 +6603,8 @@
         </p:nvSpPr>
         <p:spPr>
           <a:xfrm>
-            <a:off x="1005840" y="2286000"/>
-            <a:ext cx="4572000" cy="3474720"/>
+            <a:off x="1005840" y="2240280"/>
+            <a:ext cx="4663440" cy="3749040"/>
           </a:xfrm>
           <a:prstGeom prst="rect">
             <a:avLst/>
@@ -6611,7 +6642,7 @@
                 <a:ea typeface="Calibri" pitchFamily="34" charset="-122"/>
                 <a:cs typeface="Calibri" pitchFamily="34" charset="-120"/>
               </a:rPr>
-              <a:t>Responsive 9x9 interactive grid with distinct visual demarcations for 3x3 blocks.
+              <a:t>Responsive 9x9 grid with distinct visual borders for each 3x3 block.
 </a:t>
             </a:r>
             <a:pPr indent="0" marL="0">
@@ -6640,7 +6671,7 @@
                 <a:ea typeface="Calibri" pitchFamily="34" charset="-122"/>
                 <a:cs typeface="Calibri" pitchFamily="34" charset="-120"/>
               </a:rPr>
-              <a:t>Calls findConflicts() on every user input, instantly highlighting duplicate entries in rows, columns, or boxes in red.
+              <a:t>Calls findConflicts() on every input, instantly highlighting duplicates in rows, columns, or boxes in red.
 </a:t>
             </a:r>
             <a:pPr indent="0" marL="0">
@@ -6655,7 +6686,7 @@
                 <a:ea typeface="Calibri" pitchFamily="34" charset="-122"/>
                 <a:cs typeface="Calibri" pitchFamily="34" charset="-120"/>
               </a:rPr>
-              <a:t>• Multiple Operating Modes: </a:t>
+              <a:t>• Multi-Mode Operation: </a:t>
             </a:r>
             <a:pPr indent="0" marL="0">
               <a:buNone/>
@@ -6669,7 +6700,7 @@
                 <a:ea typeface="Calibri" pitchFamily="34" charset="-122"/>
                 <a:cs typeface="Calibri" pitchFamily="34" charset="-120"/>
               </a:rPr>
-              <a:t>Play mode (manual input), Check mode (verifies user solution), and Auto-Solve mode (runs CSP engine).
+              <a:t>Play mode (manual input), Check mode (verifies user), and Auto-Solve (runs CSP engine).
 </a:t>
             </a:r>
             <a:pPr indent="0" marL="0">
@@ -6684,7 +6715,7 @@
                 <a:ea typeface="Calibri" pitchFamily="34" charset="-122"/>
                 <a:cs typeface="Calibri" pitchFamily="34" charset="-120"/>
               </a:rPr>
-              <a:t>• Theme Support: </a:t>
+              <a:t>• Dark / Light Themes: </a:t>
             </a:r>
             <a:pPr indent="0" marL="0">
               <a:buNone/>
@@ -6698,7 +6729,7 @@
                 <a:ea typeface="Calibri" pitchFamily="34" charset="-122"/>
                 <a:cs typeface="Calibri" pitchFamily="34" charset="-120"/>
               </a:rPr>
-              <a:t>Dark / Light modes for accessible visual contrast.</a:t>
+              <a:t>Tailwind CSS styling with full theme toggle support.</a:t>
             </a:r>
             <a:endParaRPr lang="en-US" sz="1300" dirty="0"/>
           </a:p>
@@ -6712,12 +6743,12 @@
         </p:nvSpPr>
         <p:spPr>
           <a:xfrm>
-            <a:off x="6217920" y="1645920"/>
-            <a:ext cx="5212080" cy="4389120"/>
+            <a:off x="6245352" y="1508760"/>
+            <a:ext cx="5212080" cy="4754880"/>
           </a:xfrm>
           <a:prstGeom prst="roundRect">
             <a:avLst>
-              <a:gd name="adj" fmla="val 2083"/>
+              <a:gd name="adj" fmla="val 1923"/>
             </a:avLst>
           </a:prstGeom>
           <a:solidFill>
@@ -6739,7 +6770,7 @@
         </p:nvSpPr>
         <p:spPr>
           <a:xfrm>
-            <a:off x="6492240" y="1828800"/>
+            <a:off x="6519672" y="1737360"/>
             <a:ext cx="4663440" cy="365760"/>
           </a:xfrm>
           <a:prstGeom prst="rect">
@@ -6778,8 +6809,8 @@
         </p:nvSpPr>
         <p:spPr>
           <a:xfrm>
-            <a:off x="6492240" y="2286000"/>
-            <a:ext cx="4663440" cy="3474720"/>
+            <a:off x="6519672" y="2240280"/>
+            <a:ext cx="4663440" cy="3749040"/>
           </a:xfrm>
           <a:prstGeom prst="rect">
             <a:avLst/>
@@ -6904,7 +6935,7 @@
                 <a:ea typeface="Calibri" pitchFamily="34" charset="-122"/>
                 <a:cs typeface="Calibri" pitchFamily="34" charset="-120"/>
               </a:rPr>
-              <a:t>CSP algorithm logic (canPlace, solveSudoku) is purely functional and cleanly separated from UI rendering.</a:t>
+              <a:t>CSP algorithm logic (canPlace, solveSudoku) is purely functional and separated from UI rendering.</a:t>
             </a:r>
             <a:endParaRPr lang="en-US" sz="1300" dirty="0"/>
           </a:p>
@@ -6950,8 +6981,8 @@
         </p:nvSpPr>
         <p:spPr>
           <a:xfrm>
-            <a:off x="731520" y="457200"/>
-            <a:ext cx="7315200" cy="274320"/>
+            <a:off x="731520" y="411480"/>
+            <a:ext cx="9144000" cy="274320"/>
           </a:xfrm>
           <a:prstGeom prst="rect">
             <a:avLst/>
@@ -6989,8 +7020,8 @@
         </p:nvSpPr>
         <p:spPr>
           <a:xfrm>
-            <a:off x="731520" y="731520"/>
-            <a:ext cx="10515600" cy="640080"/>
+            <a:off x="731520" y="685800"/>
+            <a:ext cx="10698480" cy="548640"/>
           </a:xfrm>
           <a:prstGeom prst="rect">
             <a:avLst/>
@@ -7006,7 +7037,7 @@
               <a:buNone/>
             </a:pPr>
             <a:r>
-              <a:rPr lang="en-US" sz="2400" b="1" dirty="0">
+              <a:rPr lang="en-US" sz="2200" b="1" dirty="0">
                 <a:solidFill>
                   <a:srgbClr val="FFFFFF"/>
                 </a:solidFill>
@@ -7016,7 +7047,7 @@
               </a:rPr>
               <a:t>Computational Complexity &amp; NP-Completeness</a:t>
             </a:r>
-            <a:endParaRPr lang="en-US" sz="2400" dirty="0"/>
+            <a:endParaRPr lang="en-US" sz="2200" dirty="0"/>
           </a:p>
         </p:txBody>
       </p:sp>
@@ -7028,8 +7059,8 @@
         </p:nvSpPr>
         <p:spPr>
           <a:xfrm>
-            <a:off x="731520" y="1417320"/>
-            <a:ext cx="10698480" cy="18288"/>
+            <a:off x="731520" y="1298448"/>
+            <a:ext cx="10725912" cy="18288"/>
           </a:xfrm>
           <a:prstGeom prst="rect">
             <a:avLst/>
@@ -7053,12 +7084,12 @@
         </p:nvSpPr>
         <p:spPr>
           <a:xfrm>
-            <a:off x="731520" y="1645920"/>
-            <a:ext cx="5120640" cy="4389120"/>
+            <a:off x="731520" y="1508760"/>
+            <a:ext cx="5212080" cy="4754880"/>
           </a:xfrm>
           <a:prstGeom prst="roundRect">
             <a:avLst>
-              <a:gd name="adj" fmla="val 2083"/>
+              <a:gd name="adj" fmla="val 1923"/>
             </a:avLst>
           </a:prstGeom>
           <a:solidFill>
@@ -7080,8 +7111,8 @@
         </p:nvSpPr>
         <p:spPr>
           <a:xfrm>
-            <a:off x="1005840" y="1828800"/>
-            <a:ext cx="4572000" cy="365760"/>
+            <a:off x="1005840" y="1737360"/>
+            <a:ext cx="4663440" cy="365760"/>
           </a:xfrm>
           <a:prstGeom prst="rect">
             <a:avLst/>
@@ -7119,8 +7150,8 @@
         </p:nvSpPr>
         <p:spPr>
           <a:xfrm>
-            <a:off x="1005840" y="2286000"/>
-            <a:ext cx="4572000" cy="3474720"/>
+            <a:off x="1005840" y="2240280"/>
+            <a:ext cx="4663440" cy="3749040"/>
           </a:xfrm>
           <a:prstGeom prst="rect">
             <a:avLst/>
@@ -7187,7 +7218,7 @@
                 <a:ea typeface="Calibri" pitchFamily="34" charset="-122"/>
                 <a:cs typeface="Calibri" pitchFamily="34" charset="-120"/>
               </a:rPr>
-              <a:t>O(1) in practice for standard 9x9 puzzles (solved in under 5 ms) due to severe constraint pruning.
+              <a:t>Solved in under 5 milliseconds on modern CPUs due to domain constraint pruning.
 </a:t>
             </a:r>
             <a:pPr indent="0" marL="0">
@@ -7259,12 +7290,12 @@
         </p:nvSpPr>
         <p:spPr>
           <a:xfrm>
-            <a:off x="6217920" y="1645920"/>
-            <a:ext cx="5212080" cy="4389120"/>
+            <a:off x="6245352" y="1508760"/>
+            <a:ext cx="5212080" cy="4754880"/>
           </a:xfrm>
           <a:prstGeom prst="roundRect">
             <a:avLst>
-              <a:gd name="adj" fmla="val 2083"/>
+              <a:gd name="adj" fmla="val 1923"/>
             </a:avLst>
           </a:prstGeom>
           <a:solidFill>
@@ -7286,7 +7317,7 @@
         </p:nvSpPr>
         <p:spPr>
           <a:xfrm>
-            <a:off x="6492240" y="1828800"/>
+            <a:off x="6519672" y="1737360"/>
             <a:ext cx="4663440" cy="365760"/>
           </a:xfrm>
           <a:prstGeom prst="rect">
@@ -7325,8 +7356,8 @@
         </p:nvSpPr>
         <p:spPr>
           <a:xfrm>
-            <a:off x="6492240" y="2286000"/>
-            <a:ext cx="4663440" cy="3474720"/>
+            <a:off x="6519672" y="2240280"/>
+            <a:ext cx="4663440" cy="3749040"/>
           </a:xfrm>
           <a:prstGeom prst="rect">
             <a:avLst/>
@@ -7422,7 +7453,7 @@
                 <a:ea typeface="Calibri" pitchFamily="34" charset="-122"/>
                 <a:cs typeface="Calibri" pitchFamily="34" charset="-120"/>
               </a:rPr>
-              <a:t>Each cell assignment corresponds to selecting a row in a 0-1 matrix where each constraint must be satisfied exactly once.
+              <a:t>Each cell assignment corresponds to selecting a row in a 0-1 matrix where each constraint is met exactly once.
 </a:t>
             </a:r>
             <a:pPr indent="0" marL="0">
@@ -7437,7 +7468,7 @@
                 <a:ea typeface="Calibri" pitchFamily="34" charset="-122"/>
                 <a:cs typeface="Calibri" pitchFamily="34" charset="-120"/>
               </a:rPr>
-              <a:t>• Connection: </a:t>
+              <a:t>• Algorithmic Connection: </a:t>
             </a:r>
             <a:pPr indent="0" marL="0">
               <a:buNone/>
@@ -7451,7 +7482,7 @@
                 <a:ea typeface="Calibri" pitchFamily="34" charset="-122"/>
                 <a:cs typeface="Calibri" pitchFamily="34" charset="-120"/>
               </a:rPr>
-              <a:t>Can also be solved via Knuth's Dancing Links (Algorithm X).</a:t>
+              <a:t>Can also be modeled with Knuth's Dancing Links (Algorithm X).</a:t>
             </a:r>
             <a:endParaRPr lang="en-US" sz="1300" dirty="0"/>
           </a:p>

</xml_diff>

<commit_message>
Include Vedant Misra as co-author on presentation title and guide
</commit_message>
<xml_diff>
--- a/Sudoku_CSP_Presentation.pptx
+++ b/Sudoku_CSP_Presentation.pptx
@@ -511,7 +511,7 @@
           <a:p>
             <a:r>
               <a:rPr lang="en-US" dirty="0"/>
-              <a:t>Good morning/afternoon respected professors and examiners. Today, I am presenting my project on solving Sudoku modeled as a Constraint Satisfaction Problem within Artificial Intelligence. We formulate the game under the standard CSP triplet framework, explore systematic backtracking search with branch pruning, and demonstrate an interactive implementation with real-time constraint validation.</a:t>
+              <a:t>Good morning/afternoon respected professors and examiners. Today, we are presenting our project on solving Sudoku modeled as a Constraint Satisfaction Problem within Artificial Intelligence. We formulate the game under the standard CSP triplet framework, explore systematic backtracking search with branch pruning, and demonstrate an interactive implementation with real-time constraint validation.</a:t>
             </a:r>
             <a:endParaRPr lang="en-US" dirty="0"/>
           </a:p>
@@ -1878,7 +1878,7 @@
                 <a:ea typeface="Calibri" pitchFamily="34" charset="-122"/>
                 <a:cs typeface="Calibri" pitchFamily="34" charset="-120"/>
               </a:rPr>
-              <a:t>Presenter / Author: </a:t>
+              <a:t>Authors / Presenters: </a:t>
             </a:r>
             <a:pPr indent="0" marL="0">
               <a:buNone/>
@@ -1892,7 +1892,7 @@
                 <a:ea typeface="Calibri" pitchFamily="34" charset="-122"/>
                 <a:cs typeface="Calibri" pitchFamily="34" charset="-120"/>
               </a:rPr>
-              <a:t>Aastha Dhoundiyal
+              <a:t>Aastha Dhoundiyal  •  Vedant Misra
 </a:t>
             </a:r>
             <a:pPr indent="0" marL="0">

</xml_diff>